<commit_message>
Final deck: update pptx and ship the PDF export
- doc/Robotics_Final_Group_B9.pptx reflects the latest slide edits for
  the final review deck (23-slide structure: intro, modelling,
  kinematics, Hybrid A* + NMPC, results/limitations/future).
- doc/Robotics_Final_Group_B9.pdf is the rendered export, for sharing
  without PowerPoint.
</commit_message>
<xml_diff>
--- a/doc/Robotics_Final_Group_B9.pptx
+++ b/doc/Robotics_Final_Group_B9.pptx
@@ -5,32 +5,30 @@
     <p:sldMasterId id="2147483648" r:id="rId1"/>
   </p:sldMasterIdLst>
   <p:notesMasterIdLst>
-    <p:notesMasterId r:id="rId25"/>
+    <p:notesMasterId r:id="rId23"/>
   </p:notesMasterIdLst>
   <p:sldIdLst>
     <p:sldId id="256" r:id="rId2"/>
-    <p:sldId id="257" r:id="rId3"/>
-    <p:sldId id="258" r:id="rId4"/>
-    <p:sldId id="259" r:id="rId5"/>
-    <p:sldId id="260" r:id="rId6"/>
-    <p:sldId id="261" r:id="rId7"/>
-    <p:sldId id="262" r:id="rId8"/>
-    <p:sldId id="263" r:id="rId9"/>
-    <p:sldId id="264" r:id="rId10"/>
-    <p:sldId id="265" r:id="rId11"/>
-    <p:sldId id="266" r:id="rId12"/>
-    <p:sldId id="267" r:id="rId13"/>
-    <p:sldId id="269" r:id="rId14"/>
-    <p:sldId id="268" r:id="rId15"/>
-    <p:sldId id="270" r:id="rId16"/>
-    <p:sldId id="271" r:id="rId17"/>
-    <p:sldId id="272" r:id="rId18"/>
-    <p:sldId id="273" r:id="rId19"/>
-    <p:sldId id="274" r:id="rId20"/>
-    <p:sldId id="275" r:id="rId21"/>
-    <p:sldId id="276" r:id="rId22"/>
-    <p:sldId id="277" r:id="rId23"/>
-    <p:sldId id="278" r:id="rId24"/>
+    <p:sldId id="258" r:id="rId3"/>
+    <p:sldId id="259" r:id="rId4"/>
+    <p:sldId id="260" r:id="rId5"/>
+    <p:sldId id="261" r:id="rId6"/>
+    <p:sldId id="262" r:id="rId7"/>
+    <p:sldId id="263" r:id="rId8"/>
+    <p:sldId id="264" r:id="rId9"/>
+    <p:sldId id="265" r:id="rId10"/>
+    <p:sldId id="266" r:id="rId11"/>
+    <p:sldId id="267" r:id="rId12"/>
+    <p:sldId id="269" r:id="rId13"/>
+    <p:sldId id="268" r:id="rId14"/>
+    <p:sldId id="270" r:id="rId15"/>
+    <p:sldId id="271" r:id="rId16"/>
+    <p:sldId id="272" r:id="rId17"/>
+    <p:sldId id="273" r:id="rId18"/>
+    <p:sldId id="274" r:id="rId19"/>
+    <p:sldId id="275" r:id="rId20"/>
+    <p:sldId id="276" r:id="rId21"/>
+    <p:sldId id="277" r:id="rId22"/>
   </p:sldIdLst>
   <p:sldSz cx="12192000" cy="6858000"/>
   <p:notesSz cx="6858000" cy="12192000"/>
@@ -132,7 +130,6 @@
         <p14:section name="Introduction" id="{D4308CBF-5A55-B5F3-AD3A-2B3A9CFC0098}">
           <p14:sldIdLst>
             <p14:sldId id="256"/>
-            <p14:sldId id="257"/>
             <p14:sldId id="258"/>
             <p14:sldId id="259"/>
           </p14:sldIdLst>
@@ -173,7 +170,6 @@
         <p14:section name="Closing" id="{3B139018-0C97-01E6-EBB8-C2AE4AC3CE65}">
           <p14:sldIdLst>
             <p14:sldId id="277"/>
-            <p14:sldId id="278"/>
           </p14:sldIdLst>
         </p14:section>
       </p14:sectionLst>
@@ -446,11 +442,10 @@
             <a:r>
               <a:rPr lang="en-US" dirty="0"/>
               <a:t>[Part 2, Person B]
-We start with the tractor alone. Each axle's two wheels are lumped into one wheel on the centre line: the kinematic bicycle model.
-Because no wheel may slide sideways, the line through each wheel's axle must pass through one common point, the instantaneous centre of rotation. The rear axle is perpendicular to the body, the front axle is turned by delta, and the geometry of that triangle gives the turning radius R = L1 / tan delta.
-The rear axle moves along the heading at speed v, so x-dot is v cos theta0 and y-dot is v sin theta0.
-It moves on a circle of radius R, so the heading changes at v over R, which is v tan delta over L1.
-These three equations are the first three of our model.</a:t>
+Now the trailer. Step 1, rigid-body transform: the hitch sits a distance d ahead of the tractor rear axle along the tractor heading.
+Step 2: the trailer axle is L2 behind the hitch along the trailer heading theta1.
+Step 3 is the no-slip constraint at the trailer axle. Differentiate the hitch position: its velocity v_h is the rear-axle velocity plus d times theta0-dot sideways. Split v_h into a part along the trailer and a part across it, v-perpendicular. The trailer axle cannot slide, so the along part just drags the trailer straight, and the across part rotates the trailer about its axle, with radius L2.
+Working out the components: v-perpendicular is v sin psi plus d theta0-dot cos psi, so theta1-dot is that over L2.</a:t>
             </a:r>
           </a:p>
         </p:txBody>
@@ -538,10 +533,10 @@
             <a:r>
               <a:rPr lang="en-US" dirty="0"/>
               <a:t>[Part 2, Person B]
-Now the trailer. Step 1, rigid-body transform: the hitch sits a distance d ahead of the tractor rear axle along the tractor heading.
-Step 2: the trailer axle is L2 behind the hitch along the trailer heading theta1.
-Step 3 is the no-slip constraint at the trailer axle. Differentiate the hitch position: its velocity v_h is the rear-axle velocity plus d times theta0-dot sideways. Split v_h into a part along the trailer and a part across it, v-perpendicular. The trailer axle cannot slide, so the along part just drags the trailer straight, and the across part rotates the trailer about its axle, with radius L2.
-Working out the components: v-perpendicular is v sin psi plus d theta0-dot cos psi, so theta1-dot is that over L2.</a:t>
+Putting it together. The hitch angle is theta0 minus theta1, so its rate is theta0-dot minus theta1-dot. Substituting both, we get the fourth equation.
+It has three terms, colour coded. The teal steering term is the only way the driver influences psi. The red hitch term, minus v sin psi over L2, is the trailer's own reaction. The grey term exists because the hitch is 0.5 m ahead of the rear axle; it is a few per cent.
+Notice every term is multiplied by v: the path the rig traces depends on distance travelled, not on speed. So we choose the path first and the speed separately.
+We integrate these four equations with fourth-order Runge-Kutta, and exactly this model is used by the planner, the controller and the viewer.</a:t>
             </a:r>
           </a:p>
         </p:txBody>
@@ -626,14 +621,7 @@
           <a:bodyPr/>
           <a:lstStyle/>
           <a:p>
-            <a:r>
-              <a:rPr lang="en-US" dirty="0"/>
-              <a:t>[Part 2, Person B]
-Putting it together. The hitch angle is theta0 minus theta1, so its rate is theta0-dot minus theta1-dot. Substituting both, we get the fourth equation.
-It has three terms, colour coded. The teal steering term is the only way the driver influences psi. The red hitch term, minus v sin psi over L2, is the trailer's own reaction. The grey term exists because the hitch is 0.5 m ahead of the rear axle; it is a few per cent.
-Notice every term is multiplied by v: the path the rig traces depends on distance travelled, not on speed. So we choose the path first and the speed separately.
-We integrate these four equations with fourth-order Runge-Kutta, and exactly this model is used by the planner, the controller and the viewer.</a:t>
-            </a:r>
+            <a:endParaRPr lang="en-US" dirty="0"/>
           </a:p>
         </p:txBody>
       </p:sp>
@@ -717,7 +705,15 @@
           <a:bodyPr/>
           <a:lstStyle/>
           <a:p>
-            <a:endParaRPr lang="en-US" dirty="0"/>
+            <a:r>
+              <a:rPr lang="en-US" dirty="0"/>
+              <a:t>[Part 2, Person B: the key insight of the whole project]
+Take the hitch equation with straight steering and a small angle, so sin psi is about psi. We get psi-dot = minus v over L2 times psi: a first-order system with eigenvalue lambda = minus v over L2.
+Driving forward, v is positive, lambda is negative, and any hitch angle dies out: the trailer straightens itself.
+Reversing, v is negative, lambda is positive, and the angle grows exponentially, by a factor e every L2 = 8 metres travelled.
+The graph is the exact solution, not a simulation: starting from just 2 degrees, reversing reaches the 60 degree limit after 28 metres, while forward it vanishes.
+This is why a simple reactive controller fails, and why Part 3 needs a planner and a predictive controller.</a:t>
+            </a:r>
           </a:p>
         </p:txBody>
       </p:sp>
@@ -803,12 +799,10 @@
           <a:p>
             <a:r>
               <a:rPr lang="en-US" dirty="0"/>
-              <a:t>[Part 2, Person B: the key insight of the whole project]
-Take the hitch equation with straight steering and a small angle, so sin psi is about psi. We get psi-dot = minus v over L2 times psi: a first-order system with eigenvalue lambda = minus v over L2.
-Driving forward, v is positive, lambda is negative, and any hitch angle dies out: the trailer straightens itself.
-Reversing, v is negative, lambda is positive, and the angle grows exponentially, by a factor e every L2 = 8 metres travelled.
-The graph is the exact solution, not a simulation: starting from just 2 degrees, reversing reaches the 60 degree limit after 28 metres, while forward it vanishes.
-This is why a simple reactive controller fails, and why Part 3 needs a planner and a predictive controller.</a:t>
+              <a:t>[Part 3, Person C: Hybrid A*]
+In general: A* is a graph search. It keeps a list of open cells and always expands the one with the lowest f = g + h, where g is the cost so far and h an estimate of the cost to go. With an admissible h it finds the shortest path. But on a grid the path has sharp corners, and a 12 metre truck cannot turn on the spot.
+Hybrid A*, from the Stanford DARPA Urban Challenge team (Dolgov 2010), fixes this: each node stores the exact continuous pose, and children are generated by simulating short drivable arcs with the vehicle model. The grid is used only to detect that two nodes are about the same.
+In our project: the search state includes the hitch angle psi. From every node we try ten arcs, two metres each, forward and reverse, each steering the hitch toward 0, plus or minus 25 or plus or minus 45 degrees. Because reversing is unstable, each arc uses a small feedback law that holds the hitch at its target; without it, reverse arcs blow up. Any arc that goes beyond 52 degrees, which keeps margin below 60, or comes within 35 cm of an obstacle is discarded. The cost to go is the shortest Dubins path of the trailer axle, because the trailer axle behaves like a car whose steering is the hitch angle.</a:t>
             </a:r>
           </a:p>
         </p:txBody>
@@ -895,10 +889,12 @@
           <a:p>
             <a:r>
               <a:rPr lang="en-US" dirty="0"/>
-              <a:t>[Part 3, Person C: Hybrid A*]
-In general: A* is a graph search. It keeps a list of open cells and always expands the one with the lowest f = g + h, where g is the cost so far and h an estimate of the cost to go. With an admissible h it finds the shortest path. But on a grid the path has sharp corners, and a 12 metre truck cannot turn on the spot.
-Hybrid A*, from the Stanford DARPA Urban Challenge team (Dolgov 2010), fixes this: each node stores the exact continuous pose, and children are generated by simulating short drivable arcs with the vehicle model. The grid is used only to detect that two nodes are about the same.
-In our project: the search state includes the hitch angle psi. From every node we try ten arcs, two metres each, forward and reverse, each steering the hitch toward 0, plus or minus 25 or plus or minus 45 degrees. Because reversing is unstable, each arc uses a small feedback law that holds the hitch at its target; without it, reverse arcs blow up. Any arc that goes beyond 52 degrees, which keeps margin below 60, or comes within 35 cm of an obstacle is discarded. The cost to go is the shortest Dubins path of the trailer axle, because the trailer axle behaves like a car whose steering is the hitch angle.</a:t>
+              <a:t>[Part 3, Person C: NMPC]
+In general, model predictive control works like a chess player. At every step it uses the model to predict the next few seconds, picks the sequence of inputs that minimises a cost while respecting hard limits, applies only the first input, then measures again and repeats. 'Nonlinear' means we predict with the full nonlinear model from Part 2, not a linearised one.
+In our project: the horizon is 9.6 seconds, 24 steps of 0.4 s, which is longer than the instability needs to grow, so the controller sees the jackknife coming. To keep it fast we choose only 8 steering moves, each held for 1.2 s.
+The cost at the bottom penalises distance from the planned path, mainly the trailer axle, plus steering effort and changes of steering so the wheel does not jerk.
+The hitch limit of 60 degrees, the 35 degree steering lock and 25 cm clearance are hard constraints: the solver may not violate them, rather than just paying a penalty.
+SciPy's SLSQP solves it in 19 to 42 milliseconds, far inside the quarter-second control period.</a:t>
             </a:r>
           </a:p>
         </p:txBody>
@@ -985,12 +981,11 @@
           <a:p>
             <a:r>
               <a:rPr lang="en-US" dirty="0"/>
-              <a:t>[Part 3, Person C: NMPC]
-In general, model predictive control works like a chess player. At every step it uses the model to predict the next few seconds, picks the sequence of inputs that minimises a cost while respecting hard limits, applies only the first input, then measures again and repeats. 'Nonlinear' means we predict with the full nonlinear model from Part 2, not a linearised one.
-In our project: the horizon is 9.6 seconds, 24 steps of 0.4 s, which is longer than the instability needs to grow, so the controller sees the jackknife coming. To keep it fast we choose only 8 steering moves, each held for 1.2 s.
-The cost at the bottom penalises distance from the planned path, mainly the trailer axle, plus steering effort and changes of steering so the wheel does not jerk.
-The hitch limit of 60 degrees, the 35 degree steering lock and 25 cm clearance are hard constraints: the solver may not violate them, rather than just paying a penalty.
-SciPy's SLSQP solves it in 19 to 42 milliseconds, far inside the quarter-second control period.</a:t>
+              <a:t>[Part 3, Person C: tying it to our project]
+The pipeline: the user picks a yard layout and a free bay. Hybrid A* plans the whole route once, from the gate to the bay, including where to stop and switch into reverse.
+NMPC then follows that route in closed loop every quarter second, and it is the NMPC that guarantees the 60 degree hitch limit, even when the truck drifts or is disturbed.
+Finally the guidance layer turns the controller's steering angles into something a person can follow: gear, speed in km/h, steering-wheel turns and how far to hold them.
+Why both? The planner is global but open loop; on its own, a small error in reverse grows, as Part 2 showed. The controller is closed loop but local; on its own, it does not know how to get around a parked truck. Together: the planner says which way, the controller says how to steer now.</a:t>
             </a:r>
           </a:p>
         </p:txBody>
@@ -1075,14 +1070,7 @@
           <a:bodyPr/>
           <a:lstStyle/>
           <a:p>
-            <a:r>
-              <a:rPr lang="en-US" dirty="0"/>
-              <a:t>[Part 3, Person C: tying it to our project]
-The pipeline: the user picks a yard layout and a free bay. Hybrid A* plans the whole route once, from the gate to the bay, including where to stop and switch into reverse.
-NMPC then follows that route in closed loop every quarter second, and it is the NMPC that guarantees the 60 degree hitch limit, even when the truck drifts or is disturbed.
-Finally the guidance layer turns the controller's steering angles into something a person can follow: gear, speed in km/h, steering-wheel turns and how far to hold them.
-Why both? The planner is global but open loop; on its own, a small error in reverse grows, as Part 2 showed. The controller is closed loop but local; on its own, it does not know how to get around a parked truck. Together: the planner says which way, the controller says how to steer now.</a:t>
-            </a:r>
+            <a:endParaRPr lang="en-US" dirty="0"/>
           </a:p>
         </p:txBody>
       </p:sp>
@@ -1166,7 +1154,13 @@
           <a:bodyPr/>
           <a:lstStyle/>
           <a:p>
-            <a:endParaRPr lang="en-US" dirty="0"/>
+            <a:r>
+              <a:rPr lang="en-US" dirty="0"/>
+              <a:t>[Part 4, Person D: results first, briefly]
+We tested four layouts, cross, angled, parallel and tandem, each with six random fills of parked trucks: 110 free bays. Every bay was planned, driven by the NMPC and checked: within 0.8 m of the bay centre, within 10 degrees of heading, never above 60 degrees of hitch, never closer than 10 cm to anything.
+All 110 pass. The hitch limit was never violated; the worst case was 50.1 degrees. On the same paths, a driver model with no hitch awareness jackknifed on all 72 reversing manoeuvres.
+The plot is one bay: the NMPC deliberately swings the hitch to about minus 48 degrees and brings it back; the unaided run passes 60 and folds.</a:t>
+            </a:r>
           </a:p>
         </p:txBody>
       </p:sp>
@@ -1252,10 +1246,12 @@
           <a:p>
             <a:r>
               <a:rPr lang="en-US" dirty="0"/>
-              <a:t>[Part 4, Person D: results first, briefly]
-We tested four layouts, cross, angled, parallel and tandem, each with six random fills of parked trucks: 110 free bays. Every bay was planned, driven by the NMPC and checked: within 0.8 m of the bay centre, within 10 degrees of heading, never above 60 degrees of hitch, never closer than 10 cm to anything.
-All 110 pass. The hitch limit was never violated; the worst case was 50.1 degrees. On the same paths, a driver model with no hitch awareness jackknifed on all 72 reversing manoeuvres.
-The plot is one bay: the NMPC deliberately swings the hitch to about minus 48 degrees and brings it back; the unaided run passes 60 and folds.</a:t>
+              <a:t>[Part 4, Person D]
+Limitations, honestly. One: the model is kinematic, it assumes the wheels never slip. At yard speeds of a few km/h that holds to a few centimetres, inside our clearance margin, but not on ice or at speed.
+Two: we assume the truck's position and hitch angle are known. A real truck needs sensors to measure them.
+Three: one trailer and a simulated yard.
+Four: the solver runs on a laptop for one user; very tight bays can take the planner several seconds.
+Future scope, mapping to those: add camera and LiDAR state estimation, which is the sensing layer base paper [1] proposes; a dedicated NMPC solver like acados to handle tighter yards in real time; re-planning inside the loop when the truck drifts; trials with human drivers following the instructions, and double-trailer road trains, which add another unstable mode.</a:t>
             </a:r>
           </a:p>
         </p:txBody>
@@ -1342,10 +1338,10 @@
           <a:p>
             <a:r>
               <a:rPr lang="en-US" dirty="0"/>
-              <a:t>[Part 0, intro]
-These are Mahindra's BE 6 and XEV 9e. Their top variants come with Autopark: twelve ultrasonic sensors, and the car parks itself in perpendicular, angled and parallel bays, the same three layouts our project uses.
-So self-parking is already a product for a car. The question we asked is: what about the vehicle that needs it most, a truck with a trailer? That is the next slide.
-(If asked: the feature is from Mahindra's own launch material for the Pack Three variants; we use the cars only as motivation, not as our platform.)</a:t>
+              <a:t>[Part 0, intro, continued]
+A car is one rigid body with three numbers to describe it: position and heading. A tractor-trailer is two bodies joined at a hitch, so it needs four.
+More importantly, a car reversing is stable. A trailer reversing is not: the hitch angle grows on its own until the trailer folds against the cab. That is a jackknife, and the picture is our simulator with no guidance.
+Nobody sells Autopark for an articulated truck. Our goal: take the truck from the gate into a chosen bay while the hitch angle never exceeds 60 degrees.</a:t>
             </a:r>
           </a:p>
         </p:txBody>
@@ -1432,12 +1428,9 @@
           <a:p>
             <a:r>
               <a:rPr lang="en-US" dirty="0"/>
-              <a:t>[Part 4, Person D]
-Limitations, honestly. One: the model is kinematic, it assumes the wheels never slip. At yard speeds of a few km/h that holds to a few centimetres, inside our clearance margin, but not on ice or at speed.
-Two: we assume the truck's position and hitch angle are known. A real truck needs sensors to measure them.
-Three: one trailer and a simulated yard.
-Four: the solver runs on a laptop for one user; very tight bays can take the planner several seconds.
-Future scope, mapping to those: add camera and LiDAR state estimation, which is the sensing layer base paper [1] proposes; a dedicated NMPC solver like acados to handle tighter yards in real time; re-planning inside the loop when the truck drifts; trials with human drivers following the instructions, and double-trailer road trains, which add another unstable mode.</a:t>
+              <a:t>[Part 4, Person D: close]
+To conclude: reversing a trailer is open-loop unstable, a 2 degree error becomes 60 in 28 metres. We modelled the rig as a nonholonomic wheeled robot, planned drivable routes with Hybrid A*, and tracked them with an NMPC that treats the hitch limit as a hard constraint. Every one of the 110 test bays parked, and every unaided reverse jackknifed. And the output is something a human driver can execute.
+Thank you; we are happy to take questions, or show the live demo.</a:t>
             </a:r>
           </a:p>
         </p:txBody>
@@ -1524,9 +1517,7 @@
           <a:p>
             <a:r>
               <a:rPr lang="en-US" dirty="0"/>
-              <a:t>[Part 4, Person D: close]
-To conclude: reversing a trailer is open-loop unstable, a 2 degree error becomes 60 in 28 metres. We modelled the rig as a nonholonomic wheeled robot, planned drivable routes with Hybrid A*, and tracked them with an NMPC that treats the hitch limit as a hard constraint. Every one of the 110 test bays parked, and every unaided reverse jackknifed. And the output is something a human driver can execute.
-Thank you; we are happy to take questions, or show the live demo.</a:t>
+              <a:t>References cited on the slides as [n]. [1] and [2] are our two base papers.</a:t>
             </a:r>
           </a:p>
         </p:txBody>
@@ -1549,180 +1540,6 @@
             <a:fld id="{F7021451-1387-4CA6-816F-3879F97B5CBC}" type="slidenum">
               <a:rPr lang="en-US"/>
               <a:t>21</a:t>
-            </a:fld>
-            <a:endParaRPr lang="en-US"/>
-          </a:p>
-        </p:txBody>
-      </p:sp>
-    </p:spTree>
-    <p:extLst>
-      <p:ext uri="{BB962C8B-B14F-4D97-AF65-F5344CB8AC3E}">
-        <p14:creationId xmlns:p14="http://schemas.microsoft.com/office/powerpoint/2010/main" val="1024086991"/>
-      </p:ext>
-    </p:extLst>
-  </p:cSld>
-  <p:clrMapOvr>
-    <a:masterClrMapping/>
-  </p:clrMapOvr>
-</p:notes>
-</file>
-
-<file path=ppt/notesSlides/notesSlide22.xml><?xml version="1.0" encoding="utf-8"?>
-<p:notes xmlns:a="http://schemas.openxmlformats.org/drawingml/2006/main" xmlns:r="http://schemas.openxmlformats.org/officeDocument/2006/relationships" xmlns:p="http://schemas.openxmlformats.org/presentationml/2006/main">
-  <p:cSld>
-    <p:spTree>
-      <p:nvGrpSpPr>
-        <p:cNvPr id="1" name=""/>
-        <p:cNvGrpSpPr/>
-        <p:nvPr/>
-      </p:nvGrpSpPr>
-      <p:grpSpPr>
-        <a:xfrm>
-          <a:off x="0" y="0"/>
-          <a:ext cx="0" cy="0"/>
-          <a:chOff x="0" y="0"/>
-          <a:chExt cx="0" cy="0"/>
-        </a:xfrm>
-      </p:grpSpPr>
-      <p:sp>
-        <p:nvSpPr>
-          <p:cNvPr id="2" name="Slide Image Placeholder 1"/>
-          <p:cNvSpPr>
-            <a:spLocks noGrp="1" noRot="1" noChangeAspect="1"/>
-          </p:cNvSpPr>
-          <p:nvPr>
-            <p:ph type="sldImg"/>
-          </p:nvPr>
-        </p:nvSpPr>
-        <p:spPr/>
-      </p:sp>
-      <p:sp>
-        <p:nvSpPr>
-          <p:cNvPr id="3" name="Notes Placeholder 2"/>
-          <p:cNvSpPr>
-            <a:spLocks noGrp="1"/>
-          </p:cNvSpPr>
-          <p:nvPr>
-            <p:ph type="body" idx="1"/>
-          </p:nvPr>
-        </p:nvSpPr>
-        <p:spPr/>
-        <p:txBody>
-          <a:bodyPr/>
-          <a:lstStyle/>
-          <a:p>
-            <a:r>
-              <a:rPr lang="en-US" dirty="0"/>
-              <a:t>References cited on the slides as [n]. [1] and [2] are our two base papers.</a:t>
-            </a:r>
-          </a:p>
-        </p:txBody>
-      </p:sp>
-      <p:sp>
-        <p:nvSpPr>
-          <p:cNvPr id="4" name="Slide Number Placeholder 3"/>
-          <p:cNvSpPr>
-            <a:spLocks noGrp="1"/>
-          </p:cNvSpPr>
-          <p:nvPr>
-            <p:ph type="sldNum" sz="quarter" idx="10"/>
-          </p:nvPr>
-        </p:nvSpPr>
-        <p:spPr/>
-        <p:txBody>
-          <a:bodyPr/>
-          <a:lstStyle/>
-          <a:p>
-            <a:fld id="{F7021451-1387-4CA6-816F-3879F97B5CBC}" type="slidenum">
-              <a:rPr lang="en-US"/>
-              <a:t>22</a:t>
-            </a:fld>
-            <a:endParaRPr lang="en-US"/>
-          </a:p>
-        </p:txBody>
-      </p:sp>
-    </p:spTree>
-    <p:extLst>
-      <p:ext uri="{BB962C8B-B14F-4D97-AF65-F5344CB8AC3E}">
-        <p14:creationId xmlns:p14="http://schemas.microsoft.com/office/powerpoint/2010/main" val="1024086991"/>
-      </p:ext>
-    </p:extLst>
-  </p:cSld>
-  <p:clrMapOvr>
-    <a:masterClrMapping/>
-  </p:clrMapOvr>
-</p:notes>
-</file>
-
-<file path=ppt/notesSlides/notesSlide23.xml><?xml version="1.0" encoding="utf-8"?>
-<p:notes xmlns:a="http://schemas.openxmlformats.org/drawingml/2006/main" xmlns:r="http://schemas.openxmlformats.org/officeDocument/2006/relationships" xmlns:p="http://schemas.openxmlformats.org/presentationml/2006/main">
-  <p:cSld>
-    <p:spTree>
-      <p:nvGrpSpPr>
-        <p:cNvPr id="1" name=""/>
-        <p:cNvGrpSpPr/>
-        <p:nvPr/>
-      </p:nvGrpSpPr>
-      <p:grpSpPr>
-        <a:xfrm>
-          <a:off x="0" y="0"/>
-          <a:ext cx="0" cy="0"/>
-          <a:chOff x="0" y="0"/>
-          <a:chExt cx="0" cy="0"/>
-        </a:xfrm>
-      </p:grpSpPr>
-      <p:sp>
-        <p:nvSpPr>
-          <p:cNvPr id="2" name="Slide Image Placeholder 1"/>
-          <p:cNvSpPr>
-            <a:spLocks noGrp="1" noRot="1" noChangeAspect="1"/>
-          </p:cNvSpPr>
-          <p:nvPr>
-            <p:ph type="sldImg"/>
-          </p:nvPr>
-        </p:nvSpPr>
-        <p:spPr/>
-      </p:sp>
-      <p:sp>
-        <p:nvSpPr>
-          <p:cNvPr id="3" name="Notes Placeholder 2"/>
-          <p:cNvSpPr>
-            <a:spLocks noGrp="1"/>
-          </p:cNvSpPr>
-          <p:nvPr>
-            <p:ph type="body" idx="1"/>
-          </p:nvPr>
-        </p:nvSpPr>
-        <p:spPr/>
-        <p:txBody>
-          <a:bodyPr/>
-          <a:lstStyle/>
-          <a:p>
-            <a:r>
-              <a:rPr lang="en-US" dirty="0"/>
-              <a:t>Offer the live demo: run v2 (run_demo.bat), pick a layout, click a green bay, show the guidance, switch to Unaided on the same bay to show the jackknife, then switch to Live and press the push button to kick the hitch 10 degrees and watch the NMPC catch it.</a:t>
-            </a:r>
-          </a:p>
-        </p:txBody>
-      </p:sp>
-      <p:sp>
-        <p:nvSpPr>
-          <p:cNvPr id="4" name="Slide Number Placeholder 3"/>
-          <p:cNvSpPr>
-            <a:spLocks noGrp="1"/>
-          </p:cNvSpPr>
-          <p:nvPr>
-            <p:ph type="sldNum" sz="quarter" idx="10"/>
-          </p:nvPr>
-        </p:nvSpPr>
-        <p:spPr/>
-        <p:txBody>
-          <a:bodyPr/>
-          <a:lstStyle/>
-          <a:p>
-            <a:fld id="{F7021451-1387-4CA6-816F-3879F97B5CBC}" type="slidenum">
-              <a:rPr lang="en-US"/>
-              <a:t>23</a:t>
             </a:fld>
             <a:endParaRPr lang="en-US"/>
           </a:p>
@@ -1787,10 +1604,11 @@
           <a:p>
             <a:r>
               <a:rPr lang="en-US" dirty="0"/>
-              <a:t>[Part 0, intro, continued]
-A car is one rigid body with three numbers to describe it: position and heading. A tractor-trailer is two bodies joined at a hitch, so it needs four.
-More importantly, a car reversing is stable. A trailer reversing is not: the hitch angle grows on its own until the trailer folds against the cab. That is a jackknife, and the picture is our simulator with no guidance.
-Nobody sells Autopark for an articulated truck. Our goal: take the truck from the gate into a chosen bay while the hitch angle never exceeds 60 degrees.</a:t>
+              <a:t>[Hand-over plan]
+Part 1, modelling: what kind of robot this is, which robotics principles apply, and the state and input variables.
+Part 2, kinematics: how the truck moves, the equations, and why reversing is unstable.
+Part 3, the two algorithms: Hybrid A* plans the route, NMPC follows it with a hard hitch limit.
+Part 4: results, limitations and future scope.</a:t>
             </a:r>
           </a:p>
         </p:txBody>
@@ -1875,14 +1693,7 @@
           <a:bodyPr/>
           <a:lstStyle/>
           <a:p>
-            <a:r>
-              <a:rPr lang="en-US" dirty="0"/>
-              <a:t>[Hand-over plan]
-Part 1, modelling: what kind of robot this is, which robotics principles apply, and the state and input variables.
-Part 2, kinematics: how the truck moves, the equations, and why reversing is unstable.
-Part 3, the two algorithms: Hybrid A* plans the route, NMPC follows it with a hard hitch limit.
-Part 4: results, limitations and future scope.</a:t>
-            </a:r>
+            <a:endParaRPr lang="en-US" dirty="0"/>
           </a:p>
         </p:txBody>
       </p:sp>
@@ -1966,7 +1777,14 @@
           <a:bodyPr/>
           <a:lstStyle/>
           <a:p>
-            <a:endParaRPr lang="en-US" dirty="0"/>
+            <a:r>
+              <a:rPr lang="en-US" dirty="0"/>
+              <a:t>[Part 1, Person A]
+We model the truck the way robotics models any wheeled mobile robot. There are two rigid bodies: the tractor, frame T, and the trailer, frame R, in a world frame W.
+They are joined by one revolute joint, the hitch, the fifth wheel. Like a joint in a robot arm it rotates about one axis, but it has no motor: it is passive.
+To say where the whole rig is we need four numbers, the configuration q: the x and y of the tractor rear axle, the tractor heading theta0 and the trailer heading theta1.
+But the driver controls only two things: speed and steering. Four coordinates, two inputs, so the system is under-actuated. The trailer goes wherever the hitch drags it.</a:t>
+            </a:r>
           </a:p>
         </p:txBody>
       </p:sp>
@@ -2052,11 +1870,11 @@
           <a:p>
             <a:r>
               <a:rPr lang="en-US" dirty="0"/>
-              <a:t>[Part 1, Person A]
-We model the truck the way robotics models any wheeled mobile robot. There are two rigid bodies: the tractor, frame T, and the trailer, frame R, in a world frame W.
-They are joined by one revolute joint, the hitch, the fifth wheel. Like a joint in a robot arm it rotates about one axis, but it has no motor: it is passive.
-To say where the whole rig is we need four numbers, the configuration q: the x and y of the tractor rear axle, the tractor heading theta0 and the trailer heading theta1.
-But the driver controls only two things: speed and steering. Four coordinates, two inputs, so the system is under-actuated. The trailer goes wherever the hitch drags it.</a:t>
+              <a:t>[Part 1, Person A: the laws of robotics that apply]
+Three principles from our robotics course give us the whole model.
+One, rigid-body transforms. Once we know where the tractor rear axle is and which way it points, the hitch and the trailer axle follow by chaining frames, exactly like forward kinematics of a two-link planar arm.
+Two, rolling without slipping. A wheel rolls along its heading but cannot slide sideways. Written as an equation, the velocity perpendicular to the wheel is zero: x-dot sin theta minus y-dot cos theta equals zero. We get one such constraint at the tractor rear axle and one at the trailer axle. These constraints are on velocities, not positions, so they cannot be integrated away: the system is nonholonomic.
+Three, it is still controllable. Four coordinates minus two velocity constraints leaves two free motions, which are exactly our two inputs. By combining them, forward, reverse, steer, the truck can still reach any position and heading; mathematically that is Chow's theorem, Lie brackets of the two input fields. In plain words: you cannot slide a truck sideways into a bay, but you can always manoeuvre into it, which is what parking is.</a:t>
             </a:r>
           </a:p>
         </p:txBody>
@@ -2143,11 +1961,11 @@
           <a:p>
             <a:r>
               <a:rPr lang="en-US" dirty="0"/>
-              <a:t>[Part 1, Person A: the laws of robotics that apply]
-Three principles from our robotics course give us the whole model.
-One, rigid-body transforms. Once we know where the tractor rear axle is and which way it points, the hitch and the trailer axle follow by chaining frames, exactly like forward kinematics of a two-link planar arm.
-Two, rolling without slipping. A wheel rolls along its heading but cannot slide sideways. Written as an equation, the velocity perpendicular to the wheel is zero: x-dot sin theta minus y-dot cos theta equals zero. We get one such constraint at the tractor rear axle and one at the trailer axle. These constraints are on velocities, not positions, so they cannot be integrated away: the system is nonholonomic.
-Three, it is still controllable. Four coordinates minus two velocity constraints leaves two free motions, which are exactly our two inputs. By combining them, forward, reverse, steer, the truck can still reach any position and heading; mathematically that is Chow's theorem, Lie brackets of the two input fields. In plain words: you cannot slide a truck sideways into a bay, but you can always manoeuvre into it, which is what parking is.</a:t>
+              <a:t>[Part 1, Person A: state and inputs]
+The state X has four entries: x1, y1, the position of the tractor rear axle; theta0, the tractor heading; and psi, the hitch angle, tractor heading minus trailer heading.
+Why psi and not theta1? They carry the same information, but psi is the quantity we must keep safe. A jackknife is psi growing too large, so we make it a state and put a hard limit on it.
+The inputs U are the two things a driver controls: speed v, negative when reversing, and the front-wheel steering angle delta.
+Parameters along the bottom: a 4 m tractor wheelbase L1, an 8 m trailer from hitch to axle L2, the hitch 0.5 m ahead of the rear axle d, 35 degrees of steering lock, a 60 degree hitch limit, and yard speed up to 2 m/s, about 7 km/h.</a:t>
             </a:r>
           </a:p>
         </p:txBody>
@@ -2232,14 +2050,7 @@
           <a:bodyPr/>
           <a:lstStyle/>
           <a:p>
-            <a:r>
-              <a:rPr lang="en-US" dirty="0"/>
-              <a:t>[Part 1, Person A: state and inputs]
-The state X has four entries: x1, y1, the position of the tractor rear axle; theta0, the tractor heading; and psi, the hitch angle, tractor heading minus trailer heading.
-Why psi and not theta1? They carry the same information, but psi is the quantity we must keep safe. A jackknife is psi growing too large, so we make it a state and put a hard limit on it.
-The inputs U are the two things a driver controls: speed v, negative when reversing, and the front-wheel steering angle delta.
-Parameters along the bottom: a 4 m tractor wheelbase L1, an 8 m trailer from hitch to axle L2, the hitch 0.5 m ahead of the rear axle d, 35 degrees of steering lock, a 60 degree hitch limit, and yard speed up to 2 m/s, about 7 km/h.</a:t>
-            </a:r>
+            <a:endParaRPr lang="en-US" dirty="0"/>
           </a:p>
         </p:txBody>
       </p:sp>
@@ -2323,7 +2134,15 @@
           <a:bodyPr/>
           <a:lstStyle/>
           <a:p>
-            <a:endParaRPr lang="en-US" dirty="0"/>
+            <a:r>
+              <a:rPr lang="en-US" dirty="0"/>
+              <a:t>[Part 2, Person B]
+We start with the tractor alone. Each axle's two wheels are lumped into one wheel on the centre line: the kinematic bicycle model.
+Because no wheel may slide sideways, the line through each wheel's axle must pass through one common point, the instantaneous centre of rotation. The rear axle is perpendicular to the body, the front axle is turned by delta, and the geometry of that triangle gives the turning radius R = L1 / tan delta.
+The rear axle moves along the heading at speed v, so x-dot is v cos theta0 and y-dot is v sin theta0.
+It moves on a circle of radius R, so the heading changes at v over R, which is v tan delta over L1.
+These three equations are the first three of our model.</a:t>
+            </a:r>
           </a:p>
         </p:txBody>
       </p:sp>
@@ -2671,7 +2490,7 @@
           </a:prstGeom>
           <a:extLst>
             <a:ext uri="{C572A759-6A51-4108-AA02-DFA0A04FC94B}">
-              <ma14:wrappingTextBoxFlag xmlns:ma14="http://schemas.microsoft.com/office/mac/drawingml/2011/main" xmlns="" val="0"/>
+              <ma14:wrappingTextBoxFlag xmlns="" xmlns:ma14="http://schemas.microsoft.com/office/mac/drawingml/2011/main" val="0"/>
             </a:ext>
           </a:extLst>
         </p:spPr>
@@ -2867,7 +2686,7 @@
           </a:prstGeom>
           <a:extLst>
             <a:ext uri="{C572A759-6A51-4108-AA02-DFA0A04FC94B}">
-              <ma14:wrappingTextBoxFlag xmlns:ma14="http://schemas.microsoft.com/office/mac/drawingml/2011/main" xmlns="" val="0"/>
+              <ma14:wrappingTextBoxFlag xmlns="" xmlns:ma14="http://schemas.microsoft.com/office/mac/drawingml/2011/main" val="0"/>
             </a:ext>
           </a:extLst>
         </p:spPr>
@@ -2942,7 +2761,7 @@
           </a:prstGeom>
           <a:extLst>
             <a:ext uri="{C572A759-6A51-4108-AA02-DFA0A04FC94B}">
-              <ma14:wrappingTextBoxFlag xmlns:ma14="http://schemas.microsoft.com/office/mac/drawingml/2011/main" xmlns="" val="0"/>
+              <ma14:wrappingTextBoxFlag xmlns="" xmlns:ma14="http://schemas.microsoft.com/office/mac/drawingml/2011/main" val="0"/>
             </a:ext>
           </a:extLst>
         </p:spPr>
@@ -3651,448 +3470,6 @@
 
 <file path=ppt/slides/slide10.xml><?xml version="1.0" encoding="utf-8"?>
 <p:sld xmlns:a="http://schemas.openxmlformats.org/drawingml/2006/main" xmlns:r="http://schemas.openxmlformats.org/officeDocument/2006/relationships" xmlns:p="http://schemas.openxmlformats.org/presentationml/2006/main">
-  <p:cSld name="Slide 10">
-    <p:spTree>
-      <p:nvGrpSpPr>
-        <p:cNvPr id="1" name=""/>
-        <p:cNvGrpSpPr/>
-        <p:nvPr/>
-      </p:nvGrpSpPr>
-      <p:grpSpPr>
-        <a:xfrm>
-          <a:off x="0" y="0"/>
-          <a:ext cx="0" cy="0"/>
-          <a:chOff x="0" y="0"/>
-          <a:chExt cx="0" cy="0"/>
-        </a:xfrm>
-      </p:grpSpPr>
-      <p:sp>
-        <p:nvSpPr>
-          <p:cNvPr id="2" name="badge122"/>
-          <p:cNvSpPr/>
-          <p:nvPr/>
-        </p:nvSpPr>
-        <p:spPr>
-          <a:xfrm>
-            <a:off x="548640" y="356616"/>
-            <a:ext cx="256032" cy="256032"/>
-          </a:xfrm>
-          <a:prstGeom prst="ellipse">
-            <a:avLst/>
-          </a:prstGeom>
-          <a:solidFill>
-            <a:schemeClr val="accent1"/>
-          </a:solidFill>
-          <a:ln/>
-        </p:spPr>
-      </p:sp>
-      <p:sp>
-        <p:nvSpPr>
-          <p:cNvPr id="3" name="t123"/>
-          <p:cNvSpPr txBox="1"/>
-          <p:nvPr/>
-        </p:nvSpPr>
-        <p:spPr>
-          <a:xfrm>
-            <a:off x="548640" y="356616"/>
-            <a:ext cx="256032" cy="256032"/>
-          </a:xfrm>
-          <a:prstGeom prst="rect">
-            <a:avLst/>
-          </a:prstGeom>
-          <a:noFill/>
-          <a:ln/>
-        </p:spPr>
-        <p:txBody>
-          <a:bodyPr wrap="square" lIns="0" tIns="0" rIns="0" bIns="0" rtlCol="0" anchor="ctr"/>
-          <a:lstStyle/>
-          <a:p>
-            <a:pPr marL="0" indent="0" algn="ctr">
-              <a:buNone/>
-            </a:pPr>
-            <a:r>
-              <a:rPr lang="en-US" sz="1100" b="1" dirty="0">
-                <a:solidFill>
-                  <a:schemeClr val="bg1"/>
-                </a:solidFill>
-              </a:rPr>
-              <a:t>2</a:t>
-            </a:r>
-            <a:endParaRPr lang="en-US" sz="1100" dirty="0"/>
-          </a:p>
-        </p:txBody>
-      </p:sp>
-      <p:sp>
-        <p:nvSpPr>
-          <p:cNvPr id="4" name="Text 0"/>
-          <p:cNvSpPr>
-            <a:spLocks noGrp="1"/>
-          </p:cNvSpPr>
-          <p:nvPr>
-            <p:ph type="body" idx="100" hasCustomPrompt="1"/>
-          </p:nvPr>
-        </p:nvSpPr>
-        <p:spPr>
-          <a:xfrm>
-            <a:off x="960120" y="329184"/>
-            <a:ext cx="7315200" cy="310896"/>
-          </a:xfrm>
-          <a:prstGeom prst="rect">
-            <a:avLst/>
-          </a:prstGeom>
-          <a:noFill/>
-          <a:ln/>
-        </p:spPr>
-        <p:txBody>
-          <a:bodyPr wrap="square" lIns="0" tIns="0" rIns="0" bIns="0" rtlCol="0" anchor="ctr"/>
-          <a:lstStyle/>
-          <a:p>
-            <a:pPr marL="0" indent="0">
-              <a:buNone/>
-            </a:pPr>
-            <a:r>
-              <a:rPr lang="en-US" sz="1300" b="1" dirty="0">
-                <a:solidFill>
-                  <a:schemeClr val="accent1"/>
-                </a:solidFill>
-              </a:rPr>
-              <a:t>Part 2  ·  Vehicle Kinematics</a:t>
-            </a:r>
-            <a:endParaRPr lang="en-US" sz="1300" dirty="0"/>
-          </a:p>
-        </p:txBody>
-      </p:sp>
-      <p:sp>
-        <p:nvSpPr>
-          <p:cNvPr id="5" name="Text 0"/>
-          <p:cNvSpPr>
-            <a:spLocks noGrp="1"/>
-          </p:cNvSpPr>
-          <p:nvPr>
-            <p:ph type="title" idx="101" hasCustomPrompt="1"/>
-          </p:nvPr>
-        </p:nvSpPr>
-        <p:spPr>
-          <a:xfrm>
-            <a:off x="548640" y="676656"/>
-            <a:ext cx="11094415" cy="658368"/>
-          </a:xfrm>
-          <a:prstGeom prst="rect">
-            <a:avLst/>
-          </a:prstGeom>
-          <a:noFill/>
-          <a:ln/>
-        </p:spPr>
-        <p:txBody>
-          <a:bodyPr wrap="square" lIns="0" tIns="0" rIns="0" bIns="0" rtlCol="0" anchor="ctr"/>
-          <a:lstStyle/>
-          <a:p>
-            <a:pPr marL="0" indent="0" algn="l">
-              <a:buNone/>
-            </a:pPr>
-            <a:r>
-              <a:rPr lang="en-US" sz="2800" dirty="0">
-                <a:solidFill>
-                  <a:schemeClr val="tx1"/>
-                </a:solidFill>
-              </a:rPr>
-              <a:t>The Tractor: Kinematic Bicycle Model</a:t>
-            </a:r>
-            <a:endParaRPr lang="en-US" sz="2800" dirty="0"/>
-          </a:p>
-        </p:txBody>
-      </p:sp>
-      <p:pic>
-        <p:nvPicPr>
-          <p:cNvPr id="6" name="img124" descr="Bicycle model: rear and front wheel, steering angle delta, both wheel axes meeting at the instantaneous centre of rotation at radius R"/>
-          <p:cNvPicPr>
-            <a:picLocks noChangeAspect="1"/>
-          </p:cNvPicPr>
-          <p:nvPr/>
-        </p:nvPicPr>
-        <p:blipFill>
-          <a:blip r:embed="rId3"/>
-          <a:stretch>
-            <a:fillRect/>
-          </a:stretch>
-        </p:blipFill>
-        <p:spPr>
-          <a:xfrm>
-            <a:off x="457200" y="1344168"/>
-            <a:ext cx="4928461" cy="4846320"/>
-          </a:xfrm>
-          <a:prstGeom prst="rect">
-            <a:avLst/>
-          </a:prstGeom>
-        </p:spPr>
-      </p:pic>
-      <p:sp>
-        <p:nvSpPr>
-          <p:cNvPr id="7" name="t125"/>
-          <p:cNvSpPr txBox="1"/>
-          <p:nvPr/>
-        </p:nvSpPr>
-        <p:spPr>
-          <a:xfrm>
-            <a:off x="5989320" y="1481328"/>
-            <a:ext cx="5653735" cy="1554480"/>
-          </a:xfrm>
-          <a:prstGeom prst="rect">
-            <a:avLst/>
-          </a:prstGeom>
-          <a:noFill/>
-          <a:ln/>
-        </p:spPr>
-        <p:txBody>
-          <a:bodyPr wrap="square" lIns="0" tIns="0" rIns="0" bIns="0" rtlCol="0" anchor="t"/>
-          <a:lstStyle/>
-          <a:p>
-            <a:pPr marL="203200" indent="-203200">
-              <a:spcAft>
-                <a:spcPts val="600"/>
-              </a:spcAft>
-              <a:buSzPct val="100000"/>
-              <a:buChar char="•"/>
-            </a:pPr>
-            <a:r>
-              <a:rPr lang="en-US" sz="1700" dirty="0">
-                <a:solidFill>
-                  <a:schemeClr val="tx2"/>
-                </a:solidFill>
-              </a:rPr>
-              <a:t>Front wheels lumped into one, rear wheels into one</a:t>
-            </a:r>
-            <a:endParaRPr lang="en-US" sz="1700" dirty="0"/>
-          </a:p>
-          <a:p>
-            <a:pPr marL="203200" indent="-203200">
-              <a:spcAft>
-                <a:spcPts val="600"/>
-              </a:spcAft>
-              <a:buSzPct val="100000"/>
-              <a:buChar char="•"/>
-            </a:pPr>
-            <a:r>
-              <a:rPr lang="en-US" sz="1700" dirty="0">
-                <a:solidFill>
-                  <a:schemeClr val="tx2"/>
-                </a:solidFill>
-              </a:rPr>
-              <a:t>Both wheel axes meet at the instantaneous centre of rotation (ICR)</a:t>
-            </a:r>
-            <a:endParaRPr lang="en-US" sz="1700" dirty="0"/>
-          </a:p>
-        </p:txBody>
-      </p:sp>
-      <p:pic>
-        <p:nvPicPr>
-          <p:cNvPr id="8" name="img126" descr="R equals L1 over tan delta"/>
-          <p:cNvPicPr>
-            <a:picLocks noChangeAspect="1"/>
-          </p:cNvPicPr>
-          <p:nvPr/>
-        </p:nvPicPr>
-        <p:blipFill>
-          <a:blip r:embed="rId4"/>
-          <a:stretch>
-            <a:fillRect/>
-          </a:stretch>
-        </p:blipFill>
-        <p:spPr>
-          <a:xfrm>
-            <a:off x="6309360" y="2532888"/>
-            <a:ext cx="1225296" cy="636422"/>
-          </a:xfrm>
-          <a:prstGeom prst="rect">
-            <a:avLst/>
-          </a:prstGeom>
-        </p:spPr>
-      </p:pic>
-      <p:sp>
-        <p:nvSpPr>
-          <p:cNvPr id="9" name="card127"/>
-          <p:cNvSpPr/>
-          <p:nvPr/>
-        </p:nvSpPr>
-        <p:spPr>
-          <a:xfrm>
-            <a:off x="5989320" y="3630168"/>
-            <a:ext cx="5653735" cy="1965960"/>
-          </a:xfrm>
-          <a:prstGeom prst="roundRect">
-            <a:avLst>
-              <a:gd name="adj" fmla="val 5581"/>
-            </a:avLst>
-          </a:prstGeom>
-          <a:solidFill>
-            <a:schemeClr val="accent5"/>
-          </a:solidFill>
-          <a:ln/>
-        </p:spPr>
-      </p:sp>
-      <p:sp>
-        <p:nvSpPr>
-          <p:cNvPr id="10" name="t128"/>
-          <p:cNvSpPr txBox="1"/>
-          <p:nvPr/>
-        </p:nvSpPr>
-        <p:spPr>
-          <a:xfrm>
-            <a:off x="6263640" y="3721608"/>
-            <a:ext cx="5105095" cy="365760"/>
-          </a:xfrm>
-          <a:prstGeom prst="rect">
-            <a:avLst/>
-          </a:prstGeom>
-          <a:noFill/>
-          <a:ln/>
-        </p:spPr>
-        <p:txBody>
-          <a:bodyPr wrap="square" lIns="0" tIns="0" rIns="0" bIns="0" rtlCol="0" anchor="t"/>
-          <a:lstStyle/>
-          <a:p>
-            <a:pPr marL="0" indent="0">
-              <a:buNone/>
-            </a:pPr>
-            <a:r>
-              <a:rPr lang="en-US" sz="1400" b="1" dirty="0">
-                <a:solidFill>
-                  <a:schemeClr val="accent1"/>
-                </a:solidFill>
-              </a:rPr>
-              <a:t>Rear-Axle Motion</a:t>
-            </a:r>
-            <a:endParaRPr lang="en-US" sz="1400" dirty="0"/>
-          </a:p>
-        </p:txBody>
-      </p:sp>
-      <p:pic>
-        <p:nvPicPr>
-          <p:cNvPr id="11" name="img129" descr="x1 dot equals v cos theta0"/>
-          <p:cNvPicPr>
-            <a:picLocks noChangeAspect="1"/>
-          </p:cNvPicPr>
-          <p:nvPr/>
-        </p:nvPicPr>
-        <p:blipFill>
-          <a:blip r:embed="rId5"/>
-          <a:stretch>
-            <a:fillRect/>
-          </a:stretch>
-        </p:blipFill>
-        <p:spPr>
-          <a:xfrm>
-            <a:off x="6263640" y="4178808"/>
-            <a:ext cx="1558138" cy="354787"/>
-          </a:xfrm>
-          <a:prstGeom prst="rect">
-            <a:avLst/>
-          </a:prstGeom>
-        </p:spPr>
-      </p:pic>
-      <p:pic>
-        <p:nvPicPr>
-          <p:cNvPr id="12" name="img130" descr="y1 dot equals v sin theta0"/>
-          <p:cNvPicPr>
-            <a:picLocks noChangeAspect="1"/>
-          </p:cNvPicPr>
-          <p:nvPr/>
-        </p:nvPicPr>
-        <p:blipFill>
-          <a:blip r:embed="rId6"/>
-          <a:stretch>
-            <a:fillRect/>
-          </a:stretch>
-        </p:blipFill>
-        <p:spPr>
-          <a:xfrm>
-            <a:off x="6263640" y="4818888"/>
-            <a:ext cx="1499616" cy="354787"/>
-          </a:xfrm>
-          <a:prstGeom prst="rect">
-            <a:avLst/>
-          </a:prstGeom>
-        </p:spPr>
-      </p:pic>
-      <p:pic>
-        <p:nvPicPr>
-          <p:cNvPr id="13" name="img131" descr="theta0 dot equals v over R equals v over L1 tan delta"/>
-          <p:cNvPicPr>
-            <a:picLocks noChangeAspect="1"/>
-          </p:cNvPicPr>
-          <p:nvPr/>
-        </p:nvPicPr>
-        <p:blipFill>
-          <a:blip r:embed="rId7"/>
-          <a:stretch>
-            <a:fillRect/>
-          </a:stretch>
-        </p:blipFill>
-        <p:spPr>
-          <a:xfrm>
-            <a:off x="8732520" y="4478731"/>
-            <a:ext cx="2260397" cy="588874"/>
-          </a:xfrm>
-          <a:prstGeom prst="rect">
-            <a:avLst/>
-          </a:prstGeom>
-        </p:spPr>
-      </p:pic>
-      <p:sp>
-        <p:nvSpPr>
-          <p:cNvPr id="25" name="Slide Number Placeholder 0"/>
-          <p:cNvSpPr>
-            <a:spLocks noGrp="1"/>
-          </p:cNvSpPr>
-          <p:nvPr>
-            <p:ph type="sldNum" sz="quarter" idx="4294967295"/>
-          </p:nvPr>
-        </p:nvSpPr>
-        <p:spPr>
-          <a:xfrm>
-            <a:off x="11094415" y="6355080"/>
-            <a:ext cx="548640" cy="274320"/>
-          </a:xfrm>
-          <a:prstGeom prst="rect">
-            <a:avLst/>
-          </a:prstGeom>
-          <a:extLst>
-            <a:ext uri="{C572A759-6A51-4108-AA02-DFA0A04FC94B}">
-              <ma14:wrappingTextBoxFlag xmlns:ma14="http://schemas.microsoft.com/office/mac/drawingml/2011/main" xmlns="" val="0"/>
-            </a:ext>
-          </a:extLst>
-        </p:spPr>
-        <p:txBody>
-          <a:bodyPr/>
-          <a:lstStyle>
-            <a:lvl1pPr>
-              <a:defRPr sz="1200">
-                <a:solidFill>
-                  <a:schemeClr val="accent4"/>
-                </a:solidFill>
-              </a:defRPr>
-            </a:lvl1pPr>
-          </a:lstStyle>
-          <a:p>
-            <a:pPr algn="r"/>
-            <a:fld id="{F7021451-1387-4CA6-816F-3879F97B5CBC}" type="slidenum">
-              <a:rPr lang="en-US" b="0"/>
-              <a:t>10</a:t>
-            </a:fld>
-            <a:endParaRPr lang="en-US"/>
-          </a:p>
-        </p:txBody>
-      </p:sp>
-    </p:spTree>
-  </p:cSld>
-  <p:clrMapOvr>
-    <a:masterClrMapping/>
-  </p:clrMapOvr>
-</p:sld>
-</file>
-
-<file path=ppt/slides/slide11.xml><?xml version="1.0" encoding="utf-8"?>
-<p:sld xmlns:a="http://schemas.openxmlformats.org/drawingml/2006/main" xmlns:r="http://schemas.openxmlformats.org/officeDocument/2006/relationships" xmlns:p="http://schemas.openxmlformats.org/presentationml/2006/main">
   <p:cSld name="Slide 11">
     <p:spTree>
       <p:nvGrpSpPr>
@@ -4636,7 +4013,7 @@
           </a:prstGeom>
           <a:extLst>
             <a:ext uri="{C572A759-6A51-4108-AA02-DFA0A04FC94B}">
-              <ma14:wrappingTextBoxFlag xmlns:ma14="http://schemas.microsoft.com/office/mac/drawingml/2011/main" xmlns="" val="0"/>
+              <ma14:wrappingTextBoxFlag xmlns="" xmlns:ma14="http://schemas.microsoft.com/office/mac/drawingml/2011/main" val="0"/>
             </a:ext>
           </a:extLst>
         </p:spPr>
@@ -4655,7 +4032,7 @@
             <a:pPr algn="r"/>
             <a:fld id="{F7021451-1387-4CA6-816F-3879F97B5CBC}" type="slidenum">
               <a:rPr lang="en-US" b="0"/>
-              <a:t>11</a:t>
+              <a:t>10</a:t>
             </a:fld>
             <a:endParaRPr lang="en-US"/>
           </a:p>
@@ -4669,7 +4046,7 @@
 </p:sld>
 </file>
 
-<file path=ppt/slides/slide12.xml><?xml version="1.0" encoding="utf-8"?>
+<file path=ppt/slides/slide11.xml><?xml version="1.0" encoding="utf-8"?>
 <p:sld xmlns:a="http://schemas.openxmlformats.org/drawingml/2006/main" xmlns:r="http://schemas.openxmlformats.org/officeDocument/2006/relationships" xmlns:p="http://schemas.openxmlformats.org/presentationml/2006/main">
   <p:cSld name="Slide 12">
     <p:spTree>
@@ -5360,7 +4737,7 @@
           </a:prstGeom>
           <a:extLst>
             <a:ext uri="{C572A759-6A51-4108-AA02-DFA0A04FC94B}">
-              <ma14:wrappingTextBoxFlag xmlns:ma14="http://schemas.microsoft.com/office/mac/drawingml/2011/main" xmlns="" val="0"/>
+              <ma14:wrappingTextBoxFlag xmlns="" xmlns:ma14="http://schemas.microsoft.com/office/mac/drawingml/2011/main" val="0"/>
             </a:ext>
           </a:extLst>
         </p:spPr>
@@ -5379,7 +4756,7 @@
             <a:pPr algn="r"/>
             <a:fld id="{F7021451-1387-4CA6-816F-3879F97B5CBC}" type="slidenum">
               <a:rPr lang="en-US" b="0"/>
-              <a:t>12</a:t>
+              <a:t>11</a:t>
             </a:fld>
             <a:endParaRPr lang="en-US"/>
           </a:p>
@@ -5393,7 +4770,7 @@
 </p:sld>
 </file>
 
-<file path=ppt/slides/slide13.xml><?xml version="1.0" encoding="utf-8"?>
+<file path=ppt/slides/slide12.xml><?xml version="1.0" encoding="utf-8"?>
 <p:sld xmlns:a="http://schemas.openxmlformats.org/drawingml/2006/main" xmlns:r="http://schemas.openxmlformats.org/officeDocument/2006/relationships" xmlns:p="http://schemas.openxmlformats.org/presentationml/2006/main">
   <p:cSld name="Slide 14">
     <p:spTree>
@@ -5606,7 +4983,7 @@
           </a:prstGeom>
           <a:extLst>
             <a:ext uri="{C572A759-6A51-4108-AA02-DFA0A04FC94B}">
-              <ma14:wrappingTextBoxFlag xmlns:ma14="http://schemas.microsoft.com/office/mac/drawingml/2011/main" xmlns="" val="0"/>
+              <ma14:wrappingTextBoxFlag xmlns="" xmlns:ma14="http://schemas.microsoft.com/office/mac/drawingml/2011/main" val="0"/>
             </a:ext>
           </a:extLst>
         </p:spPr>
@@ -5625,7 +5002,7 @@
             <a:pPr algn="r"/>
             <a:fld id="{F7021451-1387-4CA6-816F-3879F97B5CBC}" type="slidenum">
               <a:rPr lang="en-US" b="0"/>
-              <a:t>13</a:t>
+              <a:t>12</a:t>
             </a:fld>
             <a:endParaRPr lang="en-US"/>
           </a:p>
@@ -5639,7 +5016,7 @@
 </p:sld>
 </file>
 
-<file path=ppt/slides/slide14.xml><?xml version="1.0" encoding="utf-8"?>
+<file path=ppt/slides/slide13.xml><?xml version="1.0" encoding="utf-8"?>
 <p:sld xmlns:a="http://schemas.openxmlformats.org/drawingml/2006/main" xmlns:r="http://schemas.openxmlformats.org/officeDocument/2006/relationships" xmlns:p="http://schemas.openxmlformats.org/presentationml/2006/main">
   <p:cSld name="Slide 13">
     <p:spTree>
@@ -5970,7 +5347,7 @@
           </a:prstGeom>
           <a:extLst>
             <a:ext uri="{C572A759-6A51-4108-AA02-DFA0A04FC94B}">
-              <ma14:wrappingTextBoxFlag xmlns:ma14="http://schemas.microsoft.com/office/mac/drawingml/2011/main" xmlns="" val="0"/>
+              <ma14:wrappingTextBoxFlag xmlns="" xmlns:ma14="http://schemas.microsoft.com/office/mac/drawingml/2011/main" val="0"/>
             </a:ext>
           </a:extLst>
         </p:spPr>
@@ -5989,7 +5366,7 @@
             <a:pPr algn="r"/>
             <a:fld id="{F7021451-1387-4CA6-816F-3879F97B5CBC}" type="slidenum">
               <a:rPr lang="en-US" b="0"/>
-              <a:t>14</a:t>
+              <a:t>13</a:t>
             </a:fld>
             <a:endParaRPr lang="en-US"/>
           </a:p>
@@ -6003,7 +5380,7 @@
 </p:sld>
 </file>
 
-<file path=ppt/slides/slide15.xml><?xml version="1.0" encoding="utf-8"?>
+<file path=ppt/slides/slide14.xml><?xml version="1.0" encoding="utf-8"?>
 <p:sld xmlns:a="http://schemas.openxmlformats.org/drawingml/2006/main" xmlns:r="http://schemas.openxmlformats.org/officeDocument/2006/relationships" xmlns:p="http://schemas.openxmlformats.org/presentationml/2006/main">
   <p:cSld name="Slide 15">
     <p:spTree>
@@ -6492,7 +5869,7 @@
           </a:prstGeom>
           <a:extLst>
             <a:ext uri="{C572A759-6A51-4108-AA02-DFA0A04FC94B}">
-              <ma14:wrappingTextBoxFlag xmlns:ma14="http://schemas.microsoft.com/office/mac/drawingml/2011/main" xmlns="" val="0"/>
+              <ma14:wrappingTextBoxFlag xmlns="" xmlns:ma14="http://schemas.microsoft.com/office/mac/drawingml/2011/main" val="0"/>
             </a:ext>
           </a:extLst>
         </p:spPr>
@@ -6511,7 +5888,7 @@
             <a:pPr algn="r"/>
             <a:fld id="{F7021451-1387-4CA6-816F-3879F97B5CBC}" type="slidenum">
               <a:rPr lang="en-US" b="0"/>
-              <a:t>15</a:t>
+              <a:t>14</a:t>
             </a:fld>
             <a:endParaRPr lang="en-US"/>
           </a:p>
@@ -6525,7 +5902,7 @@
 </p:sld>
 </file>
 
-<file path=ppt/slides/slide16.xml><?xml version="1.0" encoding="utf-8"?>
+<file path=ppt/slides/slide15.xml><?xml version="1.0" encoding="utf-8"?>
 <p:sld xmlns:a="http://schemas.openxmlformats.org/drawingml/2006/main" xmlns:r="http://schemas.openxmlformats.org/officeDocument/2006/relationships" xmlns:p="http://schemas.openxmlformats.org/presentationml/2006/main">
   <p:cSld name="Slide 16">
     <p:spTree>
@@ -7228,7 +6605,7 @@
           </a:prstGeom>
           <a:extLst>
             <a:ext uri="{C572A759-6A51-4108-AA02-DFA0A04FC94B}">
-              <ma14:wrappingTextBoxFlag xmlns:ma14="http://schemas.microsoft.com/office/mac/drawingml/2011/main" xmlns="" val="0"/>
+              <ma14:wrappingTextBoxFlag xmlns="" xmlns:ma14="http://schemas.microsoft.com/office/mac/drawingml/2011/main" val="0"/>
             </a:ext>
           </a:extLst>
         </p:spPr>
@@ -7247,7 +6624,7 @@
             <a:pPr algn="r"/>
             <a:fld id="{F7021451-1387-4CA6-816F-3879F97B5CBC}" type="slidenum">
               <a:rPr lang="en-US" b="0"/>
-              <a:t>16</a:t>
+              <a:t>15</a:t>
             </a:fld>
             <a:endParaRPr lang="en-US"/>
           </a:p>
@@ -7261,7 +6638,7 @@
 </p:sld>
 </file>
 
-<file path=ppt/slides/slide17.xml><?xml version="1.0" encoding="utf-8"?>
+<file path=ppt/slides/slide16.xml><?xml version="1.0" encoding="utf-8"?>
 <p:sld xmlns:a="http://schemas.openxmlformats.org/drawingml/2006/main" xmlns:r="http://schemas.openxmlformats.org/officeDocument/2006/relationships" xmlns:p="http://schemas.openxmlformats.org/presentationml/2006/main">
   <p:cSld name="Slide 17">
     <p:spTree>
@@ -8086,7 +7463,7 @@
           </a:prstGeom>
           <a:extLst>
             <a:ext uri="{C572A759-6A51-4108-AA02-DFA0A04FC94B}">
-              <ma14:wrappingTextBoxFlag xmlns:ma14="http://schemas.microsoft.com/office/mac/drawingml/2011/main" xmlns="" val="0"/>
+              <ma14:wrappingTextBoxFlag xmlns="" xmlns:ma14="http://schemas.microsoft.com/office/mac/drawingml/2011/main" val="0"/>
             </a:ext>
           </a:extLst>
         </p:spPr>
@@ -8105,7 +7482,7 @@
             <a:pPr algn="r"/>
             <a:fld id="{F7021451-1387-4CA6-816F-3879F97B5CBC}" type="slidenum">
               <a:rPr lang="en-US" b="0"/>
-              <a:t>17</a:t>
+              <a:t>16</a:t>
             </a:fld>
             <a:endParaRPr lang="en-US"/>
           </a:p>
@@ -8119,7 +7496,7 @@
 </p:sld>
 </file>
 
-<file path=ppt/slides/slide18.xml><?xml version="1.0" encoding="utf-8"?>
+<file path=ppt/slides/slide17.xml><?xml version="1.0" encoding="utf-8"?>
 <p:sld xmlns:a="http://schemas.openxmlformats.org/drawingml/2006/main" xmlns:r="http://schemas.openxmlformats.org/officeDocument/2006/relationships" xmlns:p="http://schemas.openxmlformats.org/presentationml/2006/main">
   <p:cSld name="Slide 18">
     <p:spTree>
@@ -8332,7 +7709,7 @@
           </a:prstGeom>
           <a:extLst>
             <a:ext uri="{C572A759-6A51-4108-AA02-DFA0A04FC94B}">
-              <ma14:wrappingTextBoxFlag xmlns:ma14="http://schemas.microsoft.com/office/mac/drawingml/2011/main" xmlns="" val="0"/>
+              <ma14:wrappingTextBoxFlag xmlns="" xmlns:ma14="http://schemas.microsoft.com/office/mac/drawingml/2011/main" val="0"/>
             </a:ext>
           </a:extLst>
         </p:spPr>
@@ -8351,7 +7728,7 @@
             <a:pPr algn="r"/>
             <a:fld id="{F7021451-1387-4CA6-816F-3879F97B5CBC}" type="slidenum">
               <a:rPr lang="en-US" b="0"/>
-              <a:t>18</a:t>
+              <a:t>17</a:t>
             </a:fld>
             <a:endParaRPr lang="en-US"/>
           </a:p>
@@ -8365,7 +7742,7 @@
 </p:sld>
 </file>
 
-<file path=ppt/slides/slide19.xml><?xml version="1.0" encoding="utf-8"?>
+<file path=ppt/slides/slide18.xml><?xml version="1.0" encoding="utf-8"?>
 <p:sld xmlns:a="http://schemas.openxmlformats.org/drawingml/2006/main" xmlns:r="http://schemas.openxmlformats.org/officeDocument/2006/relationships" xmlns:p="http://schemas.openxmlformats.org/presentationml/2006/main">
   <p:cSld name="Slide 19">
     <p:spTree>
@@ -9056,7 +8433,7 @@
           </a:prstGeom>
           <a:extLst>
             <a:ext uri="{C572A759-6A51-4108-AA02-DFA0A04FC94B}">
-              <ma14:wrappingTextBoxFlag xmlns:ma14="http://schemas.microsoft.com/office/mac/drawingml/2011/main" xmlns="" val="0"/>
+              <ma14:wrappingTextBoxFlag xmlns="" xmlns:ma14="http://schemas.microsoft.com/office/mac/drawingml/2011/main" val="0"/>
             </a:ext>
           </a:extLst>
         </p:spPr>
@@ -9075,7 +8452,7 @@
             <a:pPr algn="r"/>
             <a:fld id="{F7021451-1387-4CA6-816F-3879F97B5CBC}" type="slidenum">
               <a:rPr lang="en-US" b="0"/>
-              <a:t>19</a:t>
+              <a:t>18</a:t>
             </a:fld>
             <a:endParaRPr lang="en-US"/>
           </a:p>
@@ -9089,433 +8466,7 @@
 </p:sld>
 </file>
 
-<file path=ppt/slides/slide2.xml><?xml version="1.0" encoding="utf-8"?>
-<p:sld xmlns:a="http://schemas.openxmlformats.org/drawingml/2006/main" xmlns:r="http://schemas.openxmlformats.org/officeDocument/2006/relationships" xmlns:p="http://schemas.openxmlformats.org/presentationml/2006/main">
-  <p:cSld name="Slide 2">
-    <p:spTree>
-      <p:nvGrpSpPr>
-        <p:cNvPr id="1" name=""/>
-        <p:cNvGrpSpPr/>
-        <p:nvPr/>
-      </p:nvGrpSpPr>
-      <p:grpSpPr>
-        <a:xfrm>
-          <a:off x="0" y="0"/>
-          <a:ext cx="0" cy="0"/>
-          <a:chOff x="0" y="0"/>
-          <a:chExt cx="0" cy="0"/>
-        </a:xfrm>
-      </p:grpSpPr>
-      <p:sp>
-        <p:nvSpPr>
-          <p:cNvPr id="2" name="badge9"/>
-          <p:cNvSpPr/>
-          <p:nvPr/>
-        </p:nvSpPr>
-        <p:spPr>
-          <a:xfrm>
-            <a:off x="548640" y="356616"/>
-            <a:ext cx="256032" cy="256032"/>
-          </a:xfrm>
-          <a:prstGeom prst="ellipse">
-            <a:avLst/>
-          </a:prstGeom>
-          <a:solidFill>
-            <a:schemeClr val="accent1"/>
-          </a:solidFill>
-          <a:ln/>
-        </p:spPr>
-      </p:sp>
-      <p:sp>
-        <p:nvSpPr>
-          <p:cNvPr id="3" name="t10"/>
-          <p:cNvSpPr txBox="1"/>
-          <p:nvPr/>
-        </p:nvSpPr>
-        <p:spPr>
-          <a:xfrm>
-            <a:off x="548640" y="356616"/>
-            <a:ext cx="256032" cy="256032"/>
-          </a:xfrm>
-          <a:prstGeom prst="rect">
-            <a:avLst/>
-          </a:prstGeom>
-          <a:noFill/>
-          <a:ln/>
-        </p:spPr>
-        <p:txBody>
-          <a:bodyPr wrap="square" lIns="0" tIns="0" rIns="0" bIns="0" rtlCol="0" anchor="ctr"/>
-          <a:lstStyle/>
-          <a:p>
-            <a:pPr marL="0" indent="0" algn="ctr">
-              <a:buNone/>
-            </a:pPr>
-            <a:r>
-              <a:rPr lang="en-US" sz="1100" b="1" dirty="0">
-                <a:solidFill>
-                  <a:schemeClr val="bg1"/>
-                </a:solidFill>
-              </a:rPr>
-              <a:t>0</a:t>
-            </a:r>
-            <a:endParaRPr lang="en-US" sz="1100" dirty="0"/>
-          </a:p>
-        </p:txBody>
-      </p:sp>
-      <p:sp>
-        <p:nvSpPr>
-          <p:cNvPr id="4" name="Text 0"/>
-          <p:cNvSpPr>
-            <a:spLocks noGrp="1"/>
-          </p:cNvSpPr>
-          <p:nvPr>
-            <p:ph type="body" idx="100" hasCustomPrompt="1"/>
-          </p:nvPr>
-        </p:nvSpPr>
-        <p:spPr>
-          <a:xfrm>
-            <a:off x="960120" y="329184"/>
-            <a:ext cx="7315200" cy="310896"/>
-          </a:xfrm>
-          <a:prstGeom prst="rect">
-            <a:avLst/>
-          </a:prstGeom>
-          <a:noFill/>
-          <a:ln/>
-        </p:spPr>
-        <p:txBody>
-          <a:bodyPr wrap="square" lIns="0" tIns="0" rIns="0" bIns="0" rtlCol="0" anchor="ctr"/>
-          <a:lstStyle/>
-          <a:p>
-            <a:pPr marL="0" indent="0">
-              <a:buNone/>
-            </a:pPr>
-            <a:r>
-              <a:rPr lang="en-US" sz="1300" b="1" dirty="0">
-                <a:solidFill>
-                  <a:schemeClr val="accent1"/>
-                </a:solidFill>
-              </a:rPr>
-              <a:t>Introduction</a:t>
-            </a:r>
-            <a:endParaRPr lang="en-US" sz="1300" dirty="0"/>
-          </a:p>
-        </p:txBody>
-      </p:sp>
-      <p:sp>
-        <p:nvSpPr>
-          <p:cNvPr id="5" name="Text 0"/>
-          <p:cNvSpPr>
-            <a:spLocks noGrp="1"/>
-          </p:cNvSpPr>
-          <p:nvPr>
-            <p:ph type="title" idx="101" hasCustomPrompt="1"/>
-          </p:nvPr>
-        </p:nvSpPr>
-        <p:spPr>
-          <a:xfrm>
-            <a:off x="548640" y="676656"/>
-            <a:ext cx="11094415" cy="658368"/>
-          </a:xfrm>
-          <a:prstGeom prst="rect">
-            <a:avLst/>
-          </a:prstGeom>
-          <a:noFill/>
-          <a:ln/>
-        </p:spPr>
-        <p:txBody>
-          <a:bodyPr wrap="square" lIns="0" tIns="0" rIns="0" bIns="0" rtlCol="0" anchor="ctr"/>
-          <a:lstStyle/>
-          <a:p>
-            <a:pPr marL="0" indent="0" algn="l">
-              <a:buNone/>
-            </a:pPr>
-            <a:r>
-              <a:rPr lang="en-US" sz="2800" dirty="0">
-                <a:solidFill>
-                  <a:schemeClr val="tx1"/>
-                </a:solidFill>
-              </a:rPr>
-              <a:t>Cars Can Already Park Themselves</a:t>
-            </a:r>
-            <a:endParaRPr lang="en-US" sz="2800" dirty="0"/>
-          </a:p>
-        </p:txBody>
-      </p:sp>
-      <p:pic>
-        <p:nvPicPr>
-          <p:cNvPr id="6" name="photo11" descr="Mahindra BE 6, front three-quarter view"/>
-          <p:cNvPicPr>
-            <a:picLocks noChangeAspect="1"/>
-          </p:cNvPicPr>
-          <p:nvPr/>
-        </p:nvPicPr>
-        <p:blipFill>
-          <a:blip r:embed="rId3"/>
-          <a:srcRect/>
-          <a:stretch/>
-        </p:blipFill>
-        <p:spPr>
-          <a:xfrm>
-            <a:off x="548640" y="1481328"/>
-            <a:ext cx="5440680" cy="3246120"/>
-          </a:xfrm>
-          <a:prstGeom prst="rect">
-            <a:avLst/>
-          </a:prstGeom>
-        </p:spPr>
-      </p:pic>
-      <p:pic>
-        <p:nvPicPr>
-          <p:cNvPr id="7" name="photo12" descr="Mahindra XEV 9e, front three-quarter view"/>
-          <p:cNvPicPr>
-            <a:picLocks noChangeAspect="1"/>
-          </p:cNvPicPr>
-          <p:nvPr/>
-        </p:nvPicPr>
-        <p:blipFill>
-          <a:blip r:embed="rId4"/>
-          <a:srcRect/>
-          <a:stretch/>
-        </p:blipFill>
-        <p:spPr>
-          <a:xfrm>
-            <a:off x="6202375" y="1481328"/>
-            <a:ext cx="5440680" cy="3246120"/>
-          </a:xfrm>
-          <a:prstGeom prst="rect">
-            <a:avLst/>
-          </a:prstGeom>
-        </p:spPr>
-      </p:pic>
-      <p:sp>
-        <p:nvSpPr>
-          <p:cNvPr id="8" name="t13"/>
-          <p:cNvSpPr txBox="1"/>
-          <p:nvPr/>
-        </p:nvSpPr>
-        <p:spPr>
-          <a:xfrm>
-            <a:off x="548640" y="4837176"/>
-            <a:ext cx="5440680" cy="411480"/>
-          </a:xfrm>
-          <a:prstGeom prst="rect">
-            <a:avLst/>
-          </a:prstGeom>
-          <a:noFill/>
-          <a:ln/>
-        </p:spPr>
-        <p:txBody>
-          <a:bodyPr wrap="square" lIns="0" tIns="0" rIns="0" bIns="0" rtlCol="0" anchor="t"/>
-          <a:lstStyle/>
-          <a:p>
-            <a:pPr marL="0" indent="0">
-              <a:buNone/>
-            </a:pPr>
-            <a:r>
-              <a:rPr lang="en-US" sz="1800" b="1" dirty="0">
-                <a:solidFill>
-                  <a:schemeClr val="tx1"/>
-                </a:solidFill>
-              </a:rPr>
-              <a:t>Mahindra BE 6</a:t>
-            </a:r>
-            <a:endParaRPr lang="en-US" sz="1800" dirty="0"/>
-          </a:p>
-        </p:txBody>
-      </p:sp>
-      <p:sp>
-        <p:nvSpPr>
-          <p:cNvPr id="9" name="t14"/>
-          <p:cNvSpPr txBox="1"/>
-          <p:nvPr/>
-        </p:nvSpPr>
-        <p:spPr>
-          <a:xfrm>
-            <a:off x="6202375" y="4837176"/>
-            <a:ext cx="5440680" cy="411480"/>
-          </a:xfrm>
-          <a:prstGeom prst="rect">
-            <a:avLst/>
-          </a:prstGeom>
-          <a:noFill/>
-          <a:ln/>
-        </p:spPr>
-        <p:txBody>
-          <a:bodyPr wrap="square" lIns="0" tIns="0" rIns="0" bIns="0" rtlCol="0" anchor="t"/>
-          <a:lstStyle/>
-          <a:p>
-            <a:pPr marL="0" indent="0">
-              <a:buNone/>
-            </a:pPr>
-            <a:r>
-              <a:rPr lang="en-US" sz="1800" b="1" dirty="0">
-                <a:solidFill>
-                  <a:schemeClr val="tx1"/>
-                </a:solidFill>
-              </a:rPr>
-              <a:t>Mahindra XEV 9e</a:t>
-            </a:r>
-            <a:endParaRPr lang="en-US" sz="1800" dirty="0"/>
-          </a:p>
-        </p:txBody>
-      </p:sp>
-      <p:sp>
-        <p:nvSpPr>
-          <p:cNvPr id="10" name="card15"/>
-          <p:cNvSpPr/>
-          <p:nvPr/>
-        </p:nvSpPr>
-        <p:spPr>
-          <a:xfrm>
-            <a:off x="548640" y="5349240"/>
-            <a:ext cx="11094415" cy="749808"/>
-          </a:xfrm>
-          <a:prstGeom prst="roundRect">
-            <a:avLst>
-              <a:gd name="adj" fmla="val 14634"/>
-            </a:avLst>
-          </a:prstGeom>
-          <a:solidFill>
-            <a:schemeClr val="accent5"/>
-          </a:solidFill>
-          <a:ln/>
-        </p:spPr>
-      </p:sp>
-      <p:sp>
-        <p:nvSpPr>
-          <p:cNvPr id="11" name="t16"/>
-          <p:cNvSpPr txBox="1"/>
-          <p:nvPr/>
-        </p:nvSpPr>
-        <p:spPr>
-          <a:xfrm>
-            <a:off x="822960" y="5349240"/>
-            <a:ext cx="10545775" cy="749808"/>
-          </a:xfrm>
-          <a:prstGeom prst="rect">
-            <a:avLst/>
-          </a:prstGeom>
-          <a:noFill/>
-          <a:ln/>
-        </p:spPr>
-        <p:txBody>
-          <a:bodyPr wrap="square" lIns="0" tIns="0" rIns="0" bIns="0" rtlCol="0" anchor="ctr"/>
-          <a:lstStyle/>
-          <a:p>
-            <a:pPr marL="0" indent="0">
-              <a:buNone/>
-            </a:pPr>
-            <a:r>
-              <a:rPr lang="en-US" sz="1600" b="1" dirty="0">
-                <a:solidFill>
-                  <a:schemeClr val="accent1"/>
-                </a:solidFill>
-              </a:rPr>
-              <a:t>Autopark: </a:t>
-            </a:r>
-            <a:r>
-              <a:rPr lang="en-US" sz="1600" dirty="0">
-                <a:solidFill>
-                  <a:schemeClr val="tx1"/>
-                </a:solidFill>
-              </a:rPr>
-              <a:t>12 ultrasonic sensors; self-parks in perpendicular, angled and parallel bays</a:t>
-            </a:r>
-            <a:endParaRPr lang="en-US" sz="1600" dirty="0"/>
-          </a:p>
-        </p:txBody>
-      </p:sp>
-      <p:sp>
-        <p:nvSpPr>
-          <p:cNvPr id="12" name="t17"/>
-          <p:cNvSpPr txBox="1"/>
-          <p:nvPr/>
-        </p:nvSpPr>
-        <p:spPr>
-          <a:xfrm>
-            <a:off x="7528255" y="6355080"/>
-            <a:ext cx="3474720" cy="274320"/>
-          </a:xfrm>
-          <a:prstGeom prst="rect">
-            <a:avLst/>
-          </a:prstGeom>
-          <a:noFill/>
-          <a:ln/>
-        </p:spPr>
-        <p:txBody>
-          <a:bodyPr wrap="square" lIns="0" tIns="0" rIns="0" bIns="0" rtlCol="0" anchor="t"/>
-          <a:lstStyle/>
-          <a:p>
-            <a:pPr marL="0" indent="0" algn="r">
-              <a:buNone/>
-            </a:pPr>
-            <a:r>
-              <a:rPr lang="en-US" sz="1000" dirty="0">
-                <a:solidFill>
-                  <a:schemeClr val="accent4"/>
-                </a:solidFill>
-              </a:rPr>
-              <a:t>Photos: Cppfront, Wikimedia Commons (CC0)</a:t>
-            </a:r>
-            <a:endParaRPr lang="en-US" sz="1000" dirty="0"/>
-          </a:p>
-        </p:txBody>
-      </p:sp>
-      <p:sp>
-        <p:nvSpPr>
-          <p:cNvPr id="25" name="Slide Number Placeholder 0"/>
-          <p:cNvSpPr>
-            <a:spLocks noGrp="1"/>
-          </p:cNvSpPr>
-          <p:nvPr>
-            <p:ph type="sldNum" sz="quarter" idx="4294967295"/>
-          </p:nvPr>
-        </p:nvSpPr>
-        <p:spPr>
-          <a:xfrm>
-            <a:off x="11094415" y="6355080"/>
-            <a:ext cx="548640" cy="274320"/>
-          </a:xfrm>
-          <a:prstGeom prst="rect">
-            <a:avLst/>
-          </a:prstGeom>
-          <a:extLst>
-            <a:ext uri="{C572A759-6A51-4108-AA02-DFA0A04FC94B}">
-              <ma14:wrappingTextBoxFlag xmlns:ma14="http://schemas.microsoft.com/office/mac/drawingml/2011/main" xmlns="" val="0"/>
-            </a:ext>
-          </a:extLst>
-        </p:spPr>
-        <p:txBody>
-          <a:bodyPr/>
-          <a:lstStyle>
-            <a:lvl1pPr>
-              <a:defRPr sz="1200">
-                <a:solidFill>
-                  <a:schemeClr val="accent4"/>
-                </a:solidFill>
-              </a:defRPr>
-            </a:lvl1pPr>
-          </a:lstStyle>
-          <a:p>
-            <a:pPr algn="r"/>
-            <a:fld id="{F7021451-1387-4CA6-816F-3879F97B5CBC}" type="slidenum">
-              <a:rPr lang="en-US" b="0"/>
-              <a:t>2</a:t>
-            </a:fld>
-            <a:endParaRPr lang="en-US"/>
-          </a:p>
-        </p:txBody>
-      </p:sp>
-    </p:spTree>
-  </p:cSld>
-  <p:clrMapOvr>
-    <a:masterClrMapping/>
-  </p:clrMapOvr>
-</p:sld>
-</file>
-
-<file path=ppt/slides/slide20.xml><?xml version="1.0" encoding="utf-8"?>
+<file path=ppt/slides/slide19.xml><?xml version="1.0" encoding="utf-8"?>
 <p:sld xmlns:a="http://schemas.openxmlformats.org/drawingml/2006/main" xmlns:r="http://schemas.openxmlformats.org/officeDocument/2006/relationships" xmlns:p="http://schemas.openxmlformats.org/presentationml/2006/main">
   <p:cSld name="Slide 20">
     <p:spTree>
@@ -9992,7 +8943,7 @@
           </a:prstGeom>
           <a:extLst>
             <a:ext uri="{C572A759-6A51-4108-AA02-DFA0A04FC94B}">
-              <ma14:wrappingTextBoxFlag xmlns:ma14="http://schemas.microsoft.com/office/mac/drawingml/2011/main" xmlns="" val="0"/>
+              <ma14:wrappingTextBoxFlag xmlns="" xmlns:ma14="http://schemas.microsoft.com/office/mac/drawingml/2011/main" val="0"/>
             </a:ext>
           </a:extLst>
         </p:spPr>
@@ -10011,7 +8962,7 @@
             <a:pPr algn="r"/>
             <a:fld id="{F7021451-1387-4CA6-816F-3879F97B5CBC}" type="slidenum">
               <a:rPr lang="en-US" b="0"/>
-              <a:t>20</a:t>
+              <a:t>19</a:t>
             </a:fld>
             <a:endParaRPr lang="en-US"/>
           </a:p>
@@ -10025,7 +8976,959 @@
 </p:sld>
 </file>
 
-<file path=ppt/slides/slide21.xml><?xml version="1.0" encoding="utf-8"?>
+<file path=ppt/slides/slide2.xml><?xml version="1.0" encoding="utf-8"?>
+<p:sld xmlns:a="http://schemas.openxmlformats.org/drawingml/2006/main" xmlns:r="http://schemas.openxmlformats.org/officeDocument/2006/relationships" xmlns:p="http://schemas.openxmlformats.org/presentationml/2006/main">
+  <p:cSld name="Slide 3">
+    <p:spTree>
+      <p:nvGrpSpPr>
+        <p:cNvPr id="1" name=""/>
+        <p:cNvGrpSpPr/>
+        <p:nvPr/>
+      </p:nvGrpSpPr>
+      <p:grpSpPr>
+        <a:xfrm>
+          <a:off x="0" y="0"/>
+          <a:ext cx="0" cy="0"/>
+          <a:chOff x="0" y="0"/>
+          <a:chExt cx="0" cy="0"/>
+        </a:xfrm>
+      </p:grpSpPr>
+      <p:sp>
+        <p:nvSpPr>
+          <p:cNvPr id="2" name="badge18"/>
+          <p:cNvSpPr/>
+          <p:nvPr/>
+        </p:nvSpPr>
+        <p:spPr>
+          <a:xfrm>
+            <a:off x="548640" y="356616"/>
+            <a:ext cx="256032" cy="256032"/>
+          </a:xfrm>
+          <a:prstGeom prst="ellipse">
+            <a:avLst/>
+          </a:prstGeom>
+          <a:solidFill>
+            <a:schemeClr val="accent1"/>
+          </a:solidFill>
+          <a:ln/>
+        </p:spPr>
+      </p:sp>
+      <p:sp>
+        <p:nvSpPr>
+          <p:cNvPr id="3" name="t19"/>
+          <p:cNvSpPr txBox="1"/>
+          <p:nvPr/>
+        </p:nvSpPr>
+        <p:spPr>
+          <a:xfrm>
+            <a:off x="548640" y="356616"/>
+            <a:ext cx="256032" cy="256032"/>
+          </a:xfrm>
+          <a:prstGeom prst="rect">
+            <a:avLst/>
+          </a:prstGeom>
+          <a:noFill/>
+          <a:ln/>
+        </p:spPr>
+        <p:txBody>
+          <a:bodyPr wrap="square" lIns="0" tIns="0" rIns="0" bIns="0" rtlCol="0" anchor="ctr"/>
+          <a:lstStyle/>
+          <a:p>
+            <a:pPr marL="0" indent="0" algn="ctr">
+              <a:buNone/>
+            </a:pPr>
+            <a:r>
+              <a:rPr lang="en-US" sz="1100" b="1" dirty="0">
+                <a:solidFill>
+                  <a:schemeClr val="bg1"/>
+                </a:solidFill>
+              </a:rPr>
+              <a:t>0</a:t>
+            </a:r>
+            <a:endParaRPr lang="en-US" sz="1100" dirty="0"/>
+          </a:p>
+        </p:txBody>
+      </p:sp>
+      <p:sp>
+        <p:nvSpPr>
+          <p:cNvPr id="4" name="Text 0"/>
+          <p:cNvSpPr>
+            <a:spLocks noGrp="1"/>
+          </p:cNvSpPr>
+          <p:nvPr>
+            <p:ph type="body" idx="100" hasCustomPrompt="1"/>
+          </p:nvPr>
+        </p:nvSpPr>
+        <p:spPr>
+          <a:xfrm>
+            <a:off x="960120" y="329184"/>
+            <a:ext cx="7315200" cy="310896"/>
+          </a:xfrm>
+          <a:prstGeom prst="rect">
+            <a:avLst/>
+          </a:prstGeom>
+          <a:noFill/>
+          <a:ln/>
+        </p:spPr>
+        <p:txBody>
+          <a:bodyPr wrap="square" lIns="0" tIns="0" rIns="0" bIns="0" rtlCol="0" anchor="ctr"/>
+          <a:lstStyle/>
+          <a:p>
+            <a:pPr marL="0" indent="0">
+              <a:buNone/>
+            </a:pPr>
+            <a:r>
+              <a:rPr lang="en-US" sz="1300" b="1" dirty="0">
+                <a:solidFill>
+                  <a:schemeClr val="accent1"/>
+                </a:solidFill>
+              </a:rPr>
+              <a:t>Introduction</a:t>
+            </a:r>
+            <a:endParaRPr lang="en-US" sz="1300" dirty="0"/>
+          </a:p>
+        </p:txBody>
+      </p:sp>
+      <p:sp>
+        <p:nvSpPr>
+          <p:cNvPr id="5" name="Text 0"/>
+          <p:cNvSpPr>
+            <a:spLocks noGrp="1"/>
+          </p:cNvSpPr>
+          <p:nvPr>
+            <p:ph type="title" idx="101" hasCustomPrompt="1"/>
+          </p:nvPr>
+        </p:nvSpPr>
+        <p:spPr>
+          <a:xfrm>
+            <a:off x="548640" y="676656"/>
+            <a:ext cx="11094415" cy="658368"/>
+          </a:xfrm>
+          <a:prstGeom prst="rect">
+            <a:avLst/>
+          </a:prstGeom>
+          <a:noFill/>
+          <a:ln/>
+        </p:spPr>
+        <p:txBody>
+          <a:bodyPr wrap="square" lIns="0" tIns="0" rIns="0" bIns="0" rtlCol="0" anchor="ctr"/>
+          <a:lstStyle/>
+          <a:p>
+            <a:pPr marL="0" indent="0" algn="l">
+              <a:buNone/>
+            </a:pPr>
+            <a:r>
+              <a:rPr lang="en-US" sz="2800" dirty="0">
+                <a:solidFill>
+                  <a:schemeClr val="tx1"/>
+                </a:solidFill>
+              </a:rPr>
+              <a:t>Why a Truck With a Trailer Is a Different Problem</a:t>
+            </a:r>
+            <a:endParaRPr lang="en-US" sz="2800" dirty="0"/>
+          </a:p>
+        </p:txBody>
+      </p:sp>
+      <p:sp>
+        <p:nvSpPr>
+          <p:cNvPr id="6" name="t20"/>
+          <p:cNvSpPr txBox="1"/>
+          <p:nvPr/>
+        </p:nvSpPr>
+        <p:spPr>
+          <a:xfrm>
+            <a:off x="731520" y="1527048"/>
+            <a:ext cx="2697480" cy="658368"/>
+          </a:xfrm>
+          <a:prstGeom prst="rect">
+            <a:avLst/>
+          </a:prstGeom>
+          <a:noFill/>
+          <a:ln/>
+        </p:spPr>
+        <p:txBody>
+          <a:bodyPr wrap="square" lIns="0" tIns="0" rIns="0" bIns="0" rtlCol="0" anchor="ctr"/>
+          <a:lstStyle/>
+          <a:p>
+            <a:pPr marL="0" indent="0">
+              <a:buNone/>
+            </a:pPr>
+            <a:endParaRPr lang="en-US" sz="1700" dirty="0"/>
+          </a:p>
+        </p:txBody>
+      </p:sp>
+      <p:sp>
+        <p:nvSpPr>
+          <p:cNvPr id="7" name="t21"/>
+          <p:cNvSpPr txBox="1"/>
+          <p:nvPr/>
+        </p:nvSpPr>
+        <p:spPr>
+          <a:xfrm>
+            <a:off x="3611880" y="1527048"/>
+            <a:ext cx="960120" cy="658368"/>
+          </a:xfrm>
+          <a:prstGeom prst="rect">
+            <a:avLst/>
+          </a:prstGeom>
+          <a:noFill/>
+          <a:ln/>
+        </p:spPr>
+        <p:txBody>
+          <a:bodyPr wrap="square" lIns="0" tIns="0" rIns="0" bIns="0" rtlCol="0" anchor="ctr"/>
+          <a:lstStyle/>
+          <a:p>
+            <a:pPr marL="0" indent="0">
+              <a:buNone/>
+            </a:pPr>
+            <a:r>
+              <a:rPr lang="en-US" sz="1700" b="1" dirty="0">
+                <a:solidFill>
+                  <a:schemeClr val="accent1"/>
+                </a:solidFill>
+              </a:rPr>
+              <a:t>Car</a:t>
+            </a:r>
+            <a:endParaRPr lang="en-US" sz="1700" dirty="0"/>
+          </a:p>
+        </p:txBody>
+      </p:sp>
+      <p:sp>
+        <p:nvSpPr>
+          <p:cNvPr id="8" name="t22"/>
+          <p:cNvSpPr txBox="1"/>
+          <p:nvPr/>
+        </p:nvSpPr>
+        <p:spPr>
+          <a:xfrm>
+            <a:off x="4754880" y="1527048"/>
+            <a:ext cx="2560320" cy="658368"/>
+          </a:xfrm>
+          <a:prstGeom prst="rect">
+            <a:avLst/>
+          </a:prstGeom>
+          <a:noFill/>
+          <a:ln/>
+        </p:spPr>
+        <p:txBody>
+          <a:bodyPr wrap="square" lIns="0" tIns="0" rIns="0" bIns="0" rtlCol="0" anchor="ctr"/>
+          <a:lstStyle/>
+          <a:p>
+            <a:pPr marL="0" indent="0">
+              <a:buNone/>
+            </a:pPr>
+            <a:r>
+              <a:rPr lang="en-US" sz="1700" b="1" dirty="0">
+                <a:solidFill>
+                  <a:srgbClr val="F2B45A"/>
+                </a:solidFill>
+              </a:rPr>
+              <a:t>Tractor-Trailer</a:t>
+            </a:r>
+            <a:endParaRPr lang="en-US" sz="1700" dirty="0"/>
+          </a:p>
+        </p:txBody>
+      </p:sp>
+      <p:sp>
+        <p:nvSpPr>
+          <p:cNvPr id="9" name="card23"/>
+          <p:cNvSpPr/>
+          <p:nvPr/>
+        </p:nvSpPr>
+        <p:spPr>
+          <a:xfrm>
+            <a:off x="548640" y="2240280"/>
+            <a:ext cx="6766560" cy="548640"/>
+          </a:xfrm>
+          <a:prstGeom prst="roundRect">
+            <a:avLst>
+              <a:gd name="adj" fmla="val 20000"/>
+            </a:avLst>
+          </a:prstGeom>
+          <a:solidFill>
+            <a:schemeClr val="bg2"/>
+          </a:solidFill>
+          <a:ln/>
+        </p:spPr>
+      </p:sp>
+      <p:sp>
+        <p:nvSpPr>
+          <p:cNvPr id="10" name="t24"/>
+          <p:cNvSpPr txBox="1"/>
+          <p:nvPr/>
+        </p:nvSpPr>
+        <p:spPr>
+          <a:xfrm>
+            <a:off x="731520" y="2185416"/>
+            <a:ext cx="2697480" cy="658368"/>
+          </a:xfrm>
+          <a:prstGeom prst="rect">
+            <a:avLst/>
+          </a:prstGeom>
+          <a:noFill/>
+          <a:ln/>
+        </p:spPr>
+        <p:txBody>
+          <a:bodyPr wrap="square" lIns="0" tIns="0" rIns="0" bIns="0" rtlCol="0" anchor="ctr"/>
+          <a:lstStyle/>
+          <a:p>
+            <a:pPr marL="0" indent="0">
+              <a:buNone/>
+            </a:pPr>
+            <a:r>
+              <a:rPr lang="en-US" sz="1700" b="1" dirty="0">
+                <a:solidFill>
+                  <a:schemeClr val="tx1"/>
+                </a:solidFill>
+              </a:rPr>
+              <a:t>Rigid Bodies</a:t>
+            </a:r>
+            <a:endParaRPr lang="en-US" sz="1700" dirty="0"/>
+          </a:p>
+        </p:txBody>
+      </p:sp>
+      <p:sp>
+        <p:nvSpPr>
+          <p:cNvPr id="11" name="t25"/>
+          <p:cNvSpPr txBox="1"/>
+          <p:nvPr/>
+        </p:nvSpPr>
+        <p:spPr>
+          <a:xfrm>
+            <a:off x="3611880" y="2185416"/>
+            <a:ext cx="960120" cy="658368"/>
+          </a:xfrm>
+          <a:prstGeom prst="rect">
+            <a:avLst/>
+          </a:prstGeom>
+          <a:noFill/>
+          <a:ln/>
+        </p:spPr>
+        <p:txBody>
+          <a:bodyPr wrap="square" lIns="0" tIns="0" rIns="0" bIns="0" rtlCol="0" anchor="ctr"/>
+          <a:lstStyle/>
+          <a:p>
+            <a:pPr marL="0" indent="0">
+              <a:buNone/>
+            </a:pPr>
+            <a:r>
+              <a:rPr lang="en-US" sz="1700" dirty="0">
+                <a:solidFill>
+                  <a:schemeClr val="tx2"/>
+                </a:solidFill>
+              </a:rPr>
+              <a:t>1</a:t>
+            </a:r>
+            <a:endParaRPr lang="en-US" sz="1700" dirty="0"/>
+          </a:p>
+        </p:txBody>
+      </p:sp>
+      <p:sp>
+        <p:nvSpPr>
+          <p:cNvPr id="12" name="t26"/>
+          <p:cNvSpPr txBox="1"/>
+          <p:nvPr/>
+        </p:nvSpPr>
+        <p:spPr>
+          <a:xfrm>
+            <a:off x="4754880" y="2185416"/>
+            <a:ext cx="2560320" cy="658368"/>
+          </a:xfrm>
+          <a:prstGeom prst="rect">
+            <a:avLst/>
+          </a:prstGeom>
+          <a:noFill/>
+          <a:ln/>
+        </p:spPr>
+        <p:txBody>
+          <a:bodyPr wrap="square" lIns="0" tIns="0" rIns="0" bIns="0" rtlCol="0" anchor="ctr"/>
+          <a:lstStyle/>
+          <a:p>
+            <a:pPr marL="0" indent="0">
+              <a:buNone/>
+            </a:pPr>
+            <a:r>
+              <a:rPr lang="en-US" sz="1700" dirty="0">
+                <a:solidFill>
+                  <a:schemeClr val="tx2"/>
+                </a:solidFill>
+              </a:rPr>
+              <a:t>2, joined at a hitch</a:t>
+            </a:r>
+            <a:endParaRPr lang="en-US" sz="1700" dirty="0"/>
+          </a:p>
+        </p:txBody>
+      </p:sp>
+      <p:sp>
+        <p:nvSpPr>
+          <p:cNvPr id="13" name="card27"/>
+          <p:cNvSpPr/>
+          <p:nvPr/>
+        </p:nvSpPr>
+        <p:spPr>
+          <a:xfrm>
+            <a:off x="548640" y="2898648"/>
+            <a:ext cx="6766560" cy="548640"/>
+          </a:xfrm>
+          <a:prstGeom prst="roundRect">
+            <a:avLst>
+              <a:gd name="adj" fmla="val 20000"/>
+            </a:avLst>
+          </a:prstGeom>
+          <a:solidFill>
+            <a:schemeClr val="bg1"/>
+          </a:solidFill>
+          <a:ln/>
+        </p:spPr>
+      </p:sp>
+      <p:sp>
+        <p:nvSpPr>
+          <p:cNvPr id="14" name="t28"/>
+          <p:cNvSpPr txBox="1"/>
+          <p:nvPr/>
+        </p:nvSpPr>
+        <p:spPr>
+          <a:xfrm>
+            <a:off x="731520" y="2843784"/>
+            <a:ext cx="2697480" cy="658368"/>
+          </a:xfrm>
+          <a:prstGeom prst="rect">
+            <a:avLst/>
+          </a:prstGeom>
+          <a:noFill/>
+          <a:ln/>
+        </p:spPr>
+        <p:txBody>
+          <a:bodyPr wrap="square" lIns="0" tIns="0" rIns="0" bIns="0" rtlCol="0" anchor="ctr"/>
+          <a:lstStyle/>
+          <a:p>
+            <a:pPr marL="0" indent="0">
+              <a:buNone/>
+            </a:pPr>
+            <a:r>
+              <a:rPr lang="en-US" sz="1700" b="1" dirty="0">
+                <a:solidFill>
+                  <a:schemeClr val="tx1"/>
+                </a:solidFill>
+              </a:rPr>
+              <a:t>State Variables</a:t>
+            </a:r>
+            <a:endParaRPr lang="en-US" sz="1700" dirty="0"/>
+          </a:p>
+        </p:txBody>
+      </p:sp>
+      <p:sp>
+        <p:nvSpPr>
+          <p:cNvPr id="15" name="t29"/>
+          <p:cNvSpPr txBox="1"/>
+          <p:nvPr/>
+        </p:nvSpPr>
+        <p:spPr>
+          <a:xfrm>
+            <a:off x="3611880" y="2843784"/>
+            <a:ext cx="960120" cy="658368"/>
+          </a:xfrm>
+          <a:prstGeom prst="rect">
+            <a:avLst/>
+          </a:prstGeom>
+          <a:noFill/>
+          <a:ln/>
+        </p:spPr>
+        <p:txBody>
+          <a:bodyPr wrap="square" lIns="0" tIns="0" rIns="0" bIns="0" rtlCol="0" anchor="ctr"/>
+          <a:lstStyle/>
+          <a:p>
+            <a:pPr marL="0" indent="0">
+              <a:buNone/>
+            </a:pPr>
+            <a:r>
+              <a:rPr lang="en-US" sz="1700" dirty="0">
+                <a:solidFill>
+                  <a:schemeClr val="tx2"/>
+                </a:solidFill>
+              </a:rPr>
+              <a:t>3</a:t>
+            </a:r>
+            <a:endParaRPr lang="en-US" sz="1700" dirty="0"/>
+          </a:p>
+        </p:txBody>
+      </p:sp>
+      <p:sp>
+        <p:nvSpPr>
+          <p:cNvPr id="16" name="t30"/>
+          <p:cNvSpPr txBox="1"/>
+          <p:nvPr/>
+        </p:nvSpPr>
+        <p:spPr>
+          <a:xfrm>
+            <a:off x="4754880" y="2843784"/>
+            <a:ext cx="2560320" cy="658368"/>
+          </a:xfrm>
+          <a:prstGeom prst="rect">
+            <a:avLst/>
+          </a:prstGeom>
+          <a:noFill/>
+          <a:ln/>
+        </p:spPr>
+        <p:txBody>
+          <a:bodyPr wrap="square" lIns="0" tIns="0" rIns="0" bIns="0" rtlCol="0" anchor="ctr"/>
+          <a:lstStyle/>
+          <a:p>
+            <a:pPr marL="0" indent="0">
+              <a:buNone/>
+            </a:pPr>
+            <a:r>
+              <a:rPr lang="en-US" sz="1700" dirty="0">
+                <a:solidFill>
+                  <a:schemeClr val="tx2"/>
+                </a:solidFill>
+              </a:rPr>
+              <a:t>4</a:t>
+            </a:r>
+            <a:endParaRPr lang="en-US" sz="1700" dirty="0"/>
+          </a:p>
+        </p:txBody>
+      </p:sp>
+      <p:sp>
+        <p:nvSpPr>
+          <p:cNvPr id="17" name="card31"/>
+          <p:cNvSpPr/>
+          <p:nvPr/>
+        </p:nvSpPr>
+        <p:spPr>
+          <a:xfrm>
+            <a:off x="548640" y="3557016"/>
+            <a:ext cx="6766560" cy="548640"/>
+          </a:xfrm>
+          <a:prstGeom prst="roundRect">
+            <a:avLst>
+              <a:gd name="adj" fmla="val 20000"/>
+            </a:avLst>
+          </a:prstGeom>
+          <a:solidFill>
+            <a:schemeClr val="bg2"/>
+          </a:solidFill>
+          <a:ln/>
+        </p:spPr>
+      </p:sp>
+      <p:sp>
+        <p:nvSpPr>
+          <p:cNvPr id="18" name="t32"/>
+          <p:cNvSpPr txBox="1"/>
+          <p:nvPr/>
+        </p:nvSpPr>
+        <p:spPr>
+          <a:xfrm>
+            <a:off x="731520" y="3502152"/>
+            <a:ext cx="2697480" cy="658368"/>
+          </a:xfrm>
+          <a:prstGeom prst="rect">
+            <a:avLst/>
+          </a:prstGeom>
+          <a:noFill/>
+          <a:ln/>
+        </p:spPr>
+        <p:txBody>
+          <a:bodyPr wrap="square" lIns="0" tIns="0" rIns="0" bIns="0" rtlCol="0" anchor="ctr"/>
+          <a:lstStyle/>
+          <a:p>
+            <a:pPr marL="0" indent="0">
+              <a:buNone/>
+            </a:pPr>
+            <a:r>
+              <a:rPr lang="en-US" sz="1700" b="1" dirty="0">
+                <a:solidFill>
+                  <a:schemeClr val="tx1"/>
+                </a:solidFill>
+              </a:rPr>
+              <a:t>Reversing</a:t>
+            </a:r>
+            <a:endParaRPr lang="en-US" sz="1700" dirty="0"/>
+          </a:p>
+        </p:txBody>
+      </p:sp>
+      <p:sp>
+        <p:nvSpPr>
+          <p:cNvPr id="19" name="t33"/>
+          <p:cNvSpPr txBox="1"/>
+          <p:nvPr/>
+        </p:nvSpPr>
+        <p:spPr>
+          <a:xfrm>
+            <a:off x="3611880" y="3502152"/>
+            <a:ext cx="960120" cy="658368"/>
+          </a:xfrm>
+          <a:prstGeom prst="rect">
+            <a:avLst/>
+          </a:prstGeom>
+          <a:noFill/>
+          <a:ln/>
+        </p:spPr>
+        <p:txBody>
+          <a:bodyPr wrap="square" lIns="0" tIns="0" rIns="0" bIns="0" rtlCol="0" anchor="ctr"/>
+          <a:lstStyle/>
+          <a:p>
+            <a:pPr marL="0" indent="0">
+              <a:buNone/>
+            </a:pPr>
+            <a:r>
+              <a:rPr lang="en-US" sz="1700" dirty="0">
+                <a:solidFill>
+                  <a:schemeClr val="tx2"/>
+                </a:solidFill>
+              </a:rPr>
+              <a:t>Stable</a:t>
+            </a:r>
+            <a:endParaRPr lang="en-US" sz="1700" dirty="0"/>
+          </a:p>
+        </p:txBody>
+      </p:sp>
+      <p:sp>
+        <p:nvSpPr>
+          <p:cNvPr id="20" name="t34"/>
+          <p:cNvSpPr txBox="1"/>
+          <p:nvPr/>
+        </p:nvSpPr>
+        <p:spPr>
+          <a:xfrm>
+            <a:off x="4754880" y="3502152"/>
+            <a:ext cx="2560320" cy="658368"/>
+          </a:xfrm>
+          <a:prstGeom prst="rect">
+            <a:avLst/>
+          </a:prstGeom>
+          <a:noFill/>
+          <a:ln/>
+        </p:spPr>
+        <p:txBody>
+          <a:bodyPr wrap="square" lIns="0" tIns="0" rIns="0" bIns="0" rtlCol="0" anchor="ctr"/>
+          <a:lstStyle/>
+          <a:p>
+            <a:pPr marL="0" indent="0">
+              <a:buNone/>
+            </a:pPr>
+            <a:r>
+              <a:rPr lang="en-US" sz="1700" dirty="0">
+                <a:solidFill>
+                  <a:schemeClr val="accent3"/>
+                </a:solidFill>
+              </a:rPr>
+              <a:t>Unstable: jackknifes</a:t>
+            </a:r>
+            <a:endParaRPr lang="en-US" sz="1700" dirty="0"/>
+          </a:p>
+        </p:txBody>
+      </p:sp>
+      <p:sp>
+        <p:nvSpPr>
+          <p:cNvPr id="21" name="card35"/>
+          <p:cNvSpPr/>
+          <p:nvPr/>
+        </p:nvSpPr>
+        <p:spPr>
+          <a:xfrm>
+            <a:off x="548640" y="4215384"/>
+            <a:ext cx="6766560" cy="548640"/>
+          </a:xfrm>
+          <a:prstGeom prst="roundRect">
+            <a:avLst>
+              <a:gd name="adj" fmla="val 20000"/>
+            </a:avLst>
+          </a:prstGeom>
+          <a:solidFill>
+            <a:schemeClr val="bg1"/>
+          </a:solidFill>
+          <a:ln/>
+        </p:spPr>
+      </p:sp>
+      <p:sp>
+        <p:nvSpPr>
+          <p:cNvPr id="22" name="t36"/>
+          <p:cNvSpPr txBox="1"/>
+          <p:nvPr/>
+        </p:nvSpPr>
+        <p:spPr>
+          <a:xfrm>
+            <a:off x="731520" y="4160520"/>
+            <a:ext cx="2697480" cy="658368"/>
+          </a:xfrm>
+          <a:prstGeom prst="rect">
+            <a:avLst/>
+          </a:prstGeom>
+          <a:noFill/>
+          <a:ln/>
+        </p:spPr>
+        <p:txBody>
+          <a:bodyPr wrap="square" lIns="0" tIns="0" rIns="0" bIns="0" rtlCol="0" anchor="ctr"/>
+          <a:lstStyle/>
+          <a:p>
+            <a:pPr marL="0" indent="0">
+              <a:buNone/>
+            </a:pPr>
+            <a:r>
+              <a:rPr lang="en-US" sz="1700" b="1" dirty="0">
+                <a:solidFill>
+                  <a:schemeClr val="tx1"/>
+                </a:solidFill>
+              </a:rPr>
+              <a:t>Self-Parking Today</a:t>
+            </a:r>
+            <a:endParaRPr lang="en-US" sz="1700" dirty="0"/>
+          </a:p>
+        </p:txBody>
+      </p:sp>
+      <p:sp>
+        <p:nvSpPr>
+          <p:cNvPr id="23" name="t37"/>
+          <p:cNvSpPr txBox="1"/>
+          <p:nvPr/>
+        </p:nvSpPr>
+        <p:spPr>
+          <a:xfrm>
+            <a:off x="3611880" y="4160520"/>
+            <a:ext cx="960120" cy="658368"/>
+          </a:xfrm>
+          <a:prstGeom prst="rect">
+            <a:avLst/>
+          </a:prstGeom>
+          <a:noFill/>
+          <a:ln/>
+        </p:spPr>
+        <p:txBody>
+          <a:bodyPr wrap="square" lIns="0" tIns="0" rIns="0" bIns="0" rtlCol="0" anchor="ctr"/>
+          <a:lstStyle/>
+          <a:p>
+            <a:pPr marL="0" indent="0">
+              <a:buNone/>
+            </a:pPr>
+            <a:r>
+              <a:rPr lang="en-US" sz="1700" dirty="0">
+                <a:solidFill>
+                  <a:schemeClr val="tx2"/>
+                </a:solidFill>
+              </a:rPr>
+              <a:t>Yes</a:t>
+            </a:r>
+            <a:endParaRPr lang="en-US" sz="1700" dirty="0"/>
+          </a:p>
+        </p:txBody>
+      </p:sp>
+      <p:sp>
+        <p:nvSpPr>
+          <p:cNvPr id="24" name="t38"/>
+          <p:cNvSpPr txBox="1"/>
+          <p:nvPr/>
+        </p:nvSpPr>
+        <p:spPr>
+          <a:xfrm>
+            <a:off x="4754880" y="4160520"/>
+            <a:ext cx="2560320" cy="658368"/>
+          </a:xfrm>
+          <a:prstGeom prst="rect">
+            <a:avLst/>
+          </a:prstGeom>
+          <a:noFill/>
+          <a:ln/>
+        </p:spPr>
+        <p:txBody>
+          <a:bodyPr wrap="square" lIns="0" tIns="0" rIns="0" bIns="0" rtlCol="0" anchor="ctr"/>
+          <a:lstStyle/>
+          <a:p>
+            <a:pPr marL="0" indent="0">
+              <a:buNone/>
+            </a:pPr>
+            <a:r>
+              <a:rPr lang="en-US" sz="1700" dirty="0">
+                <a:solidFill>
+                  <a:schemeClr val="tx2"/>
+                </a:solidFill>
+              </a:rPr>
+              <a:t>No</a:t>
+            </a:r>
+            <a:endParaRPr lang="en-US" sz="1700" dirty="0"/>
+          </a:p>
+        </p:txBody>
+      </p:sp>
+      <p:pic>
+        <p:nvPicPr>
+          <p:cNvPr id="25" name="img39" descr="Unaided reverse in our simulator: the trailer folds against the tractor"/>
+          <p:cNvPicPr>
+            <a:picLocks noChangeAspect="1"/>
+          </p:cNvPicPr>
+          <p:nvPr/>
+        </p:nvPicPr>
+        <p:blipFill>
+          <a:blip r:embed="rId3"/>
+          <a:stretch>
+            <a:fillRect/>
+          </a:stretch>
+        </p:blipFill>
+        <p:spPr>
+          <a:xfrm>
+            <a:off x="7543800" y="1527048"/>
+            <a:ext cx="4114800" cy="2834126"/>
+          </a:xfrm>
+          <a:prstGeom prst="rect">
+            <a:avLst/>
+          </a:prstGeom>
+        </p:spPr>
+      </p:pic>
+      <p:sp>
+        <p:nvSpPr>
+          <p:cNvPr id="26" name="t40"/>
+          <p:cNvSpPr txBox="1"/>
+          <p:nvPr/>
+        </p:nvSpPr>
+        <p:spPr>
+          <a:xfrm>
+            <a:off x="7543800" y="4407408"/>
+            <a:ext cx="4114800" cy="365760"/>
+          </a:xfrm>
+          <a:prstGeom prst="rect">
+            <a:avLst/>
+          </a:prstGeom>
+          <a:noFill/>
+          <a:ln/>
+        </p:spPr>
+        <p:txBody>
+          <a:bodyPr wrap="square" lIns="0" tIns="0" rIns="0" bIns="0" rtlCol="0" anchor="t"/>
+          <a:lstStyle/>
+          <a:p>
+            <a:pPr marL="0" indent="0" algn="r">
+              <a:buNone/>
+            </a:pPr>
+            <a:r>
+              <a:rPr lang="en-US" sz="1100" i="1" dirty="0">
+                <a:solidFill>
+                  <a:schemeClr val="accent4"/>
+                </a:solidFill>
+              </a:rPr>
+              <a:t>Unaided reverse in our simulator: the rig folds</a:t>
+            </a:r>
+            <a:endParaRPr lang="en-US" sz="1100" dirty="0"/>
+          </a:p>
+        </p:txBody>
+      </p:sp>
+      <p:sp>
+        <p:nvSpPr>
+          <p:cNvPr id="27" name="card41"/>
+          <p:cNvSpPr/>
+          <p:nvPr/>
+        </p:nvSpPr>
+        <p:spPr>
+          <a:xfrm>
+            <a:off x="548640" y="5120640"/>
+            <a:ext cx="11094415" cy="960120"/>
+          </a:xfrm>
+          <a:prstGeom prst="roundRect">
+            <a:avLst>
+              <a:gd name="adj" fmla="val 11429"/>
+            </a:avLst>
+          </a:prstGeom>
+          <a:solidFill>
+            <a:schemeClr val="accent6"/>
+          </a:solidFill>
+          <a:ln/>
+        </p:spPr>
+      </p:sp>
+      <p:sp>
+        <p:nvSpPr>
+          <p:cNvPr id="28" name="t42"/>
+          <p:cNvSpPr txBox="1"/>
+          <p:nvPr/>
+        </p:nvSpPr>
+        <p:spPr>
+          <a:xfrm>
+            <a:off x="822960" y="5120640"/>
+            <a:ext cx="10545775" cy="960120"/>
+          </a:xfrm>
+          <a:prstGeom prst="rect">
+            <a:avLst/>
+          </a:prstGeom>
+          <a:noFill/>
+          <a:ln/>
+        </p:spPr>
+        <p:txBody>
+          <a:bodyPr wrap="square" lIns="0" tIns="0" rIns="0" bIns="0" rtlCol="0" anchor="ctr"/>
+          <a:lstStyle/>
+          <a:p>
+            <a:pPr marL="0" indent="0">
+              <a:buNone/>
+            </a:pPr>
+            <a:r>
+              <a:rPr lang="en-US" sz="1700" b="1" dirty="0">
+                <a:solidFill>
+                  <a:schemeClr val="tx1"/>
+                </a:solidFill>
+              </a:rPr>
+              <a:t>Our Goal: </a:t>
+            </a:r>
+            <a:r>
+              <a:rPr lang="en-US" sz="1700" dirty="0">
+                <a:solidFill>
+                  <a:schemeClr val="tx1"/>
+                </a:solidFill>
+              </a:rPr>
+              <a:t>guide the truck from the gate into a chosen bay while the hitch angle never exceeds 60°</a:t>
+            </a:r>
+            <a:endParaRPr lang="en-US" sz="1700" dirty="0"/>
+          </a:p>
+        </p:txBody>
+      </p:sp>
+      <p:sp>
+        <p:nvSpPr>
+          <p:cNvPr id="29" name="Slide Number Placeholder 0"/>
+          <p:cNvSpPr>
+            <a:spLocks noGrp="1"/>
+          </p:cNvSpPr>
+          <p:nvPr>
+            <p:ph type="sldNum" sz="quarter" idx="4294967295"/>
+          </p:nvPr>
+        </p:nvSpPr>
+        <p:spPr>
+          <a:xfrm>
+            <a:off x="11094415" y="6355080"/>
+            <a:ext cx="548640" cy="274320"/>
+          </a:xfrm>
+          <a:prstGeom prst="rect">
+            <a:avLst/>
+          </a:prstGeom>
+          <a:extLst>
+            <a:ext uri="{C572A759-6A51-4108-AA02-DFA0A04FC94B}">
+              <ma14:wrappingTextBoxFlag xmlns="" xmlns:ma14="http://schemas.microsoft.com/office/mac/drawingml/2011/main" val="0"/>
+            </a:ext>
+          </a:extLst>
+        </p:spPr>
+        <p:txBody>
+          <a:bodyPr/>
+          <a:lstStyle>
+            <a:lvl1pPr>
+              <a:defRPr sz="1200">
+                <a:solidFill>
+                  <a:schemeClr val="accent4"/>
+                </a:solidFill>
+              </a:defRPr>
+            </a:lvl1pPr>
+          </a:lstStyle>
+          <a:p>
+            <a:pPr algn="r"/>
+            <a:fld id="{F7021451-1387-4CA6-816F-3879F97B5CBC}" type="slidenum">
+              <a:rPr lang="en-US" b="0"/>
+              <a:t>2</a:t>
+            </a:fld>
+            <a:endParaRPr lang="en-US"/>
+          </a:p>
+        </p:txBody>
+      </p:sp>
+    </p:spTree>
+  </p:cSld>
+  <p:clrMapOvr>
+    <a:masterClrMapping/>
+  </p:clrMapOvr>
+</p:sld>
+</file>
+
+<file path=ppt/slides/slide20.xml><?xml version="1.0" encoding="utf-8"?>
 <p:sld xmlns:a="http://schemas.openxmlformats.org/drawingml/2006/main" xmlns:r="http://schemas.openxmlformats.org/officeDocument/2006/relationships" xmlns:p="http://schemas.openxmlformats.org/presentationml/2006/main">
   <p:cSld name="Slide 21">
     <p:spTree>
@@ -10242,7 +10145,7 @@
         </p:nvSpPr>
         <p:spPr>
           <a:xfrm>
-            <a:off x="1325880" y="1801368"/>
+            <a:off x="1188720" y="1976296"/>
             <a:ext cx="5760720" cy="960120"/>
           </a:xfrm>
           <a:prstGeom prst="rect">
@@ -10334,7 +10237,7 @@
         </p:nvSpPr>
         <p:spPr>
           <a:xfrm>
-            <a:off x="1325880" y="2761488"/>
+            <a:off x="1257300" y="2936416"/>
             <a:ext cx="5760720" cy="960120"/>
           </a:xfrm>
           <a:prstGeom prst="rect">
@@ -10426,7 +10329,7 @@
         </p:nvSpPr>
         <p:spPr>
           <a:xfrm>
-            <a:off x="1325880" y="3721608"/>
+            <a:off x="1257300" y="3886994"/>
             <a:ext cx="5760720" cy="960120"/>
           </a:xfrm>
           <a:prstGeom prst="rect">
@@ -10518,7 +10421,7 @@
         </p:nvSpPr>
         <p:spPr>
           <a:xfrm>
-            <a:off x="1325880" y="4681728"/>
+            <a:off x="1325880" y="4847114"/>
             <a:ext cx="5760720" cy="960120"/>
           </a:xfrm>
           <a:prstGeom prst="rect">
@@ -10546,29 +10449,6 @@
           </a:p>
         </p:txBody>
       </p:sp>
-      <p:pic>
-        <p:nvPicPr>
-          <p:cNvPr id="18" name="photo272" descr="The rig parked in its bay under NMPC guidance"/>
-          <p:cNvPicPr>
-            <a:picLocks noChangeAspect="1"/>
-          </p:cNvPicPr>
-          <p:nvPr/>
-        </p:nvPicPr>
-        <p:blipFill>
-          <a:blip r:embed="rId3"/>
-          <a:srcRect/>
-          <a:stretch/>
-        </p:blipFill>
-        <p:spPr>
-          <a:xfrm>
-            <a:off x="7086600" y="1572768"/>
-            <a:ext cx="4556455" cy="4206240"/>
-          </a:xfrm>
-          <a:prstGeom prst="rect">
-            <a:avLst/>
-          </a:prstGeom>
-        </p:spPr>
-      </p:pic>
       <p:sp>
         <p:nvSpPr>
           <p:cNvPr id="25" name="Slide Number Placeholder 0"/>
@@ -10589,7 +10469,7 @@
           </a:prstGeom>
           <a:extLst>
             <a:ext uri="{C572A759-6A51-4108-AA02-DFA0A04FC94B}">
-              <ma14:wrappingTextBoxFlag xmlns:ma14="http://schemas.microsoft.com/office/mac/drawingml/2011/main" xmlns="" val="0"/>
+              <ma14:wrappingTextBoxFlag xmlns="" xmlns:ma14="http://schemas.microsoft.com/office/mac/drawingml/2011/main" val="0"/>
             </a:ext>
           </a:extLst>
         </p:spPr>
@@ -10608,7 +10488,7 @@
             <a:pPr algn="r"/>
             <a:fld id="{F7021451-1387-4CA6-816F-3879F97B5CBC}" type="slidenum">
               <a:rPr lang="en-US" b="0"/>
-              <a:t>21</a:t>
+              <a:t>20</a:t>
             </a:fld>
             <a:endParaRPr lang="en-US"/>
           </a:p>
@@ -10622,7 +10502,7 @@
 </p:sld>
 </file>
 
-<file path=ppt/slides/slide22.xml><?xml version="1.0" encoding="utf-8"?>
+<file path=ppt/slides/slide21.xml><?xml version="1.0" encoding="utf-8"?>
 <p:sld xmlns:a="http://schemas.openxmlformats.org/drawingml/2006/main" xmlns:r="http://schemas.openxmlformats.org/officeDocument/2006/relationships" xmlns:p="http://schemas.openxmlformats.org/presentationml/2006/main">
   <p:cSld name="Slide 22">
     <p:spTree>
@@ -10818,23 +10698,6 @@
             </a:r>
             <a:endParaRPr lang="en-US" sz="1400" dirty="0"/>
           </a:p>
-          <a:p>
-            <a:pPr marL="0" indent="0">
-              <a:spcAft>
-                <a:spcPts val="1000"/>
-              </a:spcAft>
-              <a:buNone/>
-            </a:pPr>
-            <a:r>
-              <a:rPr lang="en-US" sz="1400" dirty="0">
-                <a:solidFill>
-                  <a:schemeClr val="tx2"/>
-                </a:solidFill>
-              </a:rPr>
-              <a:t>[8]  Mahindra &amp; Mahindra, “Mahindra Democratises Premium EV Technology, Announces Top Variant Prices of BE 6 and XEV 9e,” press release, 2025.</a:t>
-            </a:r>
-            <a:endParaRPr lang="en-US" sz="1400" dirty="0"/>
-          </a:p>
         </p:txBody>
       </p:sp>
       <p:sp>
@@ -10857,7 +10720,7 @@
           </a:prstGeom>
           <a:extLst>
             <a:ext uri="{C572A759-6A51-4108-AA02-DFA0A04FC94B}">
-              <ma14:wrappingTextBoxFlag xmlns:ma14="http://schemas.microsoft.com/office/mac/drawingml/2011/main" xmlns="" val="0"/>
+              <ma14:wrappingTextBoxFlag xmlns="" xmlns:ma14="http://schemas.microsoft.com/office/mac/drawingml/2011/main" val="0"/>
             </a:ext>
           </a:extLst>
         </p:spPr>
@@ -10876,117 +10739,7 @@
             <a:pPr algn="r"/>
             <a:fld id="{F7021451-1387-4CA6-816F-3879F97B5CBC}" type="slidenum">
               <a:rPr lang="en-US" b="0"/>
-              <a:t>22</a:t>
-            </a:fld>
-            <a:endParaRPr lang="en-US"/>
-          </a:p>
-        </p:txBody>
-      </p:sp>
-    </p:spTree>
-  </p:cSld>
-  <p:clrMapOvr>
-    <a:masterClrMapping/>
-  </p:clrMapOvr>
-</p:sld>
-</file>
-
-<file path=ppt/slides/slide23.xml><?xml version="1.0" encoding="utf-8"?>
-<p:sld xmlns:a="http://schemas.openxmlformats.org/drawingml/2006/main" xmlns:r="http://schemas.openxmlformats.org/officeDocument/2006/relationships" xmlns:p="http://schemas.openxmlformats.org/presentationml/2006/main">
-  <p:cSld name="Slide 23">
-    <p:spTree>
-      <p:nvGrpSpPr>
-        <p:cNvPr id="1" name=""/>
-        <p:cNvGrpSpPr/>
-        <p:nvPr/>
-      </p:nvGrpSpPr>
-      <p:grpSpPr>
-        <a:xfrm>
-          <a:off x="0" y="0"/>
-          <a:ext cx="0" cy="0"/>
-          <a:chOff x="0" y="0"/>
-          <a:chExt cx="0" cy="0"/>
-        </a:xfrm>
-      </p:grpSpPr>
-      <p:sp>
-        <p:nvSpPr>
-          <p:cNvPr id="2" name="Text 0"/>
-          <p:cNvSpPr>
-            <a:spLocks noGrp="1"/>
-          </p:cNvSpPr>
-          <p:nvPr>
-            <p:ph type="title" idx="101" hasCustomPrompt="1"/>
-          </p:nvPr>
-        </p:nvSpPr>
-        <p:spPr>
-          <a:xfrm>
-            <a:off x="548792" y="3316489"/>
-            <a:ext cx="11094415" cy="658368"/>
-          </a:xfrm>
-          <a:prstGeom prst="rect">
-            <a:avLst/>
-          </a:prstGeom>
-          <a:noFill/>
-          <a:ln/>
-        </p:spPr>
-        <p:txBody>
-          <a:bodyPr wrap="square" lIns="0" tIns="0" rIns="0" bIns="0" rtlCol="0" anchor="ctr"/>
-          <a:lstStyle/>
-          <a:p>
-            <a:pPr marL="0" indent="0" algn="ctr">
-              <a:buNone/>
-            </a:pPr>
-            <a:r>
-              <a:rPr lang="en-US" sz="2800" dirty="0">
-                <a:solidFill>
-                  <a:schemeClr val="tx1"/>
-                </a:solidFill>
-              </a:rPr>
-              <a:t>Thank You</a:t>
-            </a:r>
-            <a:endParaRPr lang="en-US" sz="2800" dirty="0"/>
-          </a:p>
-        </p:txBody>
-      </p:sp>
-      <p:sp>
-        <p:nvSpPr>
-          <p:cNvPr id="25" name="Slide Number Placeholder 0"/>
-          <p:cNvSpPr>
-            <a:spLocks noGrp="1"/>
-          </p:cNvSpPr>
-          <p:nvPr>
-            <p:ph type="sldNum" sz="quarter" idx="4294967295"/>
-          </p:nvPr>
-        </p:nvSpPr>
-        <p:spPr>
-          <a:xfrm>
-            <a:off x="11094415" y="6355080"/>
-            <a:ext cx="548640" cy="274320"/>
-          </a:xfrm>
-          <a:prstGeom prst="rect">
-            <a:avLst/>
-          </a:prstGeom>
-          <a:extLst>
-            <a:ext uri="{C572A759-6A51-4108-AA02-DFA0A04FC94B}">
-              <ma14:wrappingTextBoxFlag xmlns:ma14="http://schemas.microsoft.com/office/mac/drawingml/2011/main" xmlns="" val="0"/>
-            </a:ext>
-          </a:extLst>
-        </p:spPr>
-        <p:txBody>
-          <a:bodyPr/>
-          <a:lstStyle>
-            <a:lvl1pPr>
-              <a:defRPr sz="1200">
-                <a:solidFill>
-                  <a:schemeClr val="accent4"/>
-                </a:solidFill>
-              </a:defRPr>
-            </a:lvl1pPr>
-          </a:lstStyle>
-          <a:p>
-            <a:pPr algn="r"/>
-            <a:fld id="{F7021451-1387-4CA6-816F-3879F97B5CBC}" type="slidenum">
-              <a:rPr lang="en-US" b="0"/>
-              <a:t>23</a:t>
+              <a:t>21</a:t>
             </a:fld>
             <a:endParaRPr lang="en-US"/>
           </a:p>
@@ -11001,958 +10754,6 @@
 </file>
 
 <file path=ppt/slides/slide3.xml><?xml version="1.0" encoding="utf-8"?>
-<p:sld xmlns:a="http://schemas.openxmlformats.org/drawingml/2006/main" xmlns:r="http://schemas.openxmlformats.org/officeDocument/2006/relationships" xmlns:p="http://schemas.openxmlformats.org/presentationml/2006/main">
-  <p:cSld name="Slide 3">
-    <p:spTree>
-      <p:nvGrpSpPr>
-        <p:cNvPr id="1" name=""/>
-        <p:cNvGrpSpPr/>
-        <p:nvPr/>
-      </p:nvGrpSpPr>
-      <p:grpSpPr>
-        <a:xfrm>
-          <a:off x="0" y="0"/>
-          <a:ext cx="0" cy="0"/>
-          <a:chOff x="0" y="0"/>
-          <a:chExt cx="0" cy="0"/>
-        </a:xfrm>
-      </p:grpSpPr>
-      <p:sp>
-        <p:nvSpPr>
-          <p:cNvPr id="2" name="badge18"/>
-          <p:cNvSpPr/>
-          <p:nvPr/>
-        </p:nvSpPr>
-        <p:spPr>
-          <a:xfrm>
-            <a:off x="548640" y="356616"/>
-            <a:ext cx="256032" cy="256032"/>
-          </a:xfrm>
-          <a:prstGeom prst="ellipse">
-            <a:avLst/>
-          </a:prstGeom>
-          <a:solidFill>
-            <a:schemeClr val="accent1"/>
-          </a:solidFill>
-          <a:ln/>
-        </p:spPr>
-      </p:sp>
-      <p:sp>
-        <p:nvSpPr>
-          <p:cNvPr id="3" name="t19"/>
-          <p:cNvSpPr txBox="1"/>
-          <p:nvPr/>
-        </p:nvSpPr>
-        <p:spPr>
-          <a:xfrm>
-            <a:off x="548640" y="356616"/>
-            <a:ext cx="256032" cy="256032"/>
-          </a:xfrm>
-          <a:prstGeom prst="rect">
-            <a:avLst/>
-          </a:prstGeom>
-          <a:noFill/>
-          <a:ln/>
-        </p:spPr>
-        <p:txBody>
-          <a:bodyPr wrap="square" lIns="0" tIns="0" rIns="0" bIns="0" rtlCol="0" anchor="ctr"/>
-          <a:lstStyle/>
-          <a:p>
-            <a:pPr marL="0" indent="0" algn="ctr">
-              <a:buNone/>
-            </a:pPr>
-            <a:r>
-              <a:rPr lang="en-US" sz="1100" b="1" dirty="0">
-                <a:solidFill>
-                  <a:schemeClr val="bg1"/>
-                </a:solidFill>
-              </a:rPr>
-              <a:t>0</a:t>
-            </a:r>
-            <a:endParaRPr lang="en-US" sz="1100" dirty="0"/>
-          </a:p>
-        </p:txBody>
-      </p:sp>
-      <p:sp>
-        <p:nvSpPr>
-          <p:cNvPr id="4" name="Text 0"/>
-          <p:cNvSpPr>
-            <a:spLocks noGrp="1"/>
-          </p:cNvSpPr>
-          <p:nvPr>
-            <p:ph type="body" idx="100" hasCustomPrompt="1"/>
-          </p:nvPr>
-        </p:nvSpPr>
-        <p:spPr>
-          <a:xfrm>
-            <a:off x="960120" y="329184"/>
-            <a:ext cx="7315200" cy="310896"/>
-          </a:xfrm>
-          <a:prstGeom prst="rect">
-            <a:avLst/>
-          </a:prstGeom>
-          <a:noFill/>
-          <a:ln/>
-        </p:spPr>
-        <p:txBody>
-          <a:bodyPr wrap="square" lIns="0" tIns="0" rIns="0" bIns="0" rtlCol="0" anchor="ctr"/>
-          <a:lstStyle/>
-          <a:p>
-            <a:pPr marL="0" indent="0">
-              <a:buNone/>
-            </a:pPr>
-            <a:r>
-              <a:rPr lang="en-US" sz="1300" b="1" dirty="0">
-                <a:solidFill>
-                  <a:schemeClr val="accent1"/>
-                </a:solidFill>
-              </a:rPr>
-              <a:t>Introduction</a:t>
-            </a:r>
-            <a:endParaRPr lang="en-US" sz="1300" dirty="0"/>
-          </a:p>
-        </p:txBody>
-      </p:sp>
-      <p:sp>
-        <p:nvSpPr>
-          <p:cNvPr id="5" name="Text 0"/>
-          <p:cNvSpPr>
-            <a:spLocks noGrp="1"/>
-          </p:cNvSpPr>
-          <p:nvPr>
-            <p:ph type="title" idx="101" hasCustomPrompt="1"/>
-          </p:nvPr>
-        </p:nvSpPr>
-        <p:spPr>
-          <a:xfrm>
-            <a:off x="548640" y="676656"/>
-            <a:ext cx="11094415" cy="658368"/>
-          </a:xfrm>
-          <a:prstGeom prst="rect">
-            <a:avLst/>
-          </a:prstGeom>
-          <a:noFill/>
-          <a:ln/>
-        </p:spPr>
-        <p:txBody>
-          <a:bodyPr wrap="square" lIns="0" tIns="0" rIns="0" bIns="0" rtlCol="0" anchor="ctr"/>
-          <a:lstStyle/>
-          <a:p>
-            <a:pPr marL="0" indent="0" algn="l">
-              <a:buNone/>
-            </a:pPr>
-            <a:r>
-              <a:rPr lang="en-US" sz="2800" dirty="0">
-                <a:solidFill>
-                  <a:schemeClr val="tx1"/>
-                </a:solidFill>
-              </a:rPr>
-              <a:t>Why a Truck With a Trailer Is a Different Problem</a:t>
-            </a:r>
-            <a:endParaRPr lang="en-US" sz="2800" dirty="0"/>
-          </a:p>
-        </p:txBody>
-      </p:sp>
-      <p:sp>
-        <p:nvSpPr>
-          <p:cNvPr id="6" name="t20"/>
-          <p:cNvSpPr txBox="1"/>
-          <p:nvPr/>
-        </p:nvSpPr>
-        <p:spPr>
-          <a:xfrm>
-            <a:off x="731520" y="1527048"/>
-            <a:ext cx="2697480" cy="658368"/>
-          </a:xfrm>
-          <a:prstGeom prst="rect">
-            <a:avLst/>
-          </a:prstGeom>
-          <a:noFill/>
-          <a:ln/>
-        </p:spPr>
-        <p:txBody>
-          <a:bodyPr wrap="square" lIns="0" tIns="0" rIns="0" bIns="0" rtlCol="0" anchor="ctr"/>
-          <a:lstStyle/>
-          <a:p>
-            <a:pPr marL="0" indent="0">
-              <a:buNone/>
-            </a:pPr>
-            <a:endParaRPr lang="en-US" sz="1700" dirty="0"/>
-          </a:p>
-        </p:txBody>
-      </p:sp>
-      <p:sp>
-        <p:nvSpPr>
-          <p:cNvPr id="7" name="t21"/>
-          <p:cNvSpPr txBox="1"/>
-          <p:nvPr/>
-        </p:nvSpPr>
-        <p:spPr>
-          <a:xfrm>
-            <a:off x="3611880" y="1527048"/>
-            <a:ext cx="960120" cy="658368"/>
-          </a:xfrm>
-          <a:prstGeom prst="rect">
-            <a:avLst/>
-          </a:prstGeom>
-          <a:noFill/>
-          <a:ln/>
-        </p:spPr>
-        <p:txBody>
-          <a:bodyPr wrap="square" lIns="0" tIns="0" rIns="0" bIns="0" rtlCol="0" anchor="ctr"/>
-          <a:lstStyle/>
-          <a:p>
-            <a:pPr marL="0" indent="0">
-              <a:buNone/>
-            </a:pPr>
-            <a:r>
-              <a:rPr lang="en-US" sz="1700" b="1" dirty="0">
-                <a:solidFill>
-                  <a:schemeClr val="accent1"/>
-                </a:solidFill>
-              </a:rPr>
-              <a:t>Car</a:t>
-            </a:r>
-            <a:endParaRPr lang="en-US" sz="1700" dirty="0"/>
-          </a:p>
-        </p:txBody>
-      </p:sp>
-      <p:sp>
-        <p:nvSpPr>
-          <p:cNvPr id="8" name="t22"/>
-          <p:cNvSpPr txBox="1"/>
-          <p:nvPr/>
-        </p:nvSpPr>
-        <p:spPr>
-          <a:xfrm>
-            <a:off x="4754880" y="1527048"/>
-            <a:ext cx="2560320" cy="658368"/>
-          </a:xfrm>
-          <a:prstGeom prst="rect">
-            <a:avLst/>
-          </a:prstGeom>
-          <a:noFill/>
-          <a:ln/>
-        </p:spPr>
-        <p:txBody>
-          <a:bodyPr wrap="square" lIns="0" tIns="0" rIns="0" bIns="0" rtlCol="0" anchor="ctr"/>
-          <a:lstStyle/>
-          <a:p>
-            <a:pPr marL="0" indent="0">
-              <a:buNone/>
-            </a:pPr>
-            <a:r>
-              <a:rPr lang="en-US" sz="1700" b="1" dirty="0">
-                <a:solidFill>
-                  <a:srgbClr val="F2B45A"/>
-                </a:solidFill>
-              </a:rPr>
-              <a:t>Tractor-Trailer</a:t>
-            </a:r>
-            <a:endParaRPr lang="en-US" sz="1700" dirty="0"/>
-          </a:p>
-        </p:txBody>
-      </p:sp>
-      <p:sp>
-        <p:nvSpPr>
-          <p:cNvPr id="9" name="card23"/>
-          <p:cNvSpPr/>
-          <p:nvPr/>
-        </p:nvSpPr>
-        <p:spPr>
-          <a:xfrm>
-            <a:off x="548640" y="2240280"/>
-            <a:ext cx="6766560" cy="548640"/>
-          </a:xfrm>
-          <a:prstGeom prst="roundRect">
-            <a:avLst>
-              <a:gd name="adj" fmla="val 20000"/>
-            </a:avLst>
-          </a:prstGeom>
-          <a:solidFill>
-            <a:schemeClr val="bg2"/>
-          </a:solidFill>
-          <a:ln/>
-        </p:spPr>
-      </p:sp>
-      <p:sp>
-        <p:nvSpPr>
-          <p:cNvPr id="10" name="t24"/>
-          <p:cNvSpPr txBox="1"/>
-          <p:nvPr/>
-        </p:nvSpPr>
-        <p:spPr>
-          <a:xfrm>
-            <a:off x="731520" y="2185416"/>
-            <a:ext cx="2697480" cy="658368"/>
-          </a:xfrm>
-          <a:prstGeom prst="rect">
-            <a:avLst/>
-          </a:prstGeom>
-          <a:noFill/>
-          <a:ln/>
-        </p:spPr>
-        <p:txBody>
-          <a:bodyPr wrap="square" lIns="0" tIns="0" rIns="0" bIns="0" rtlCol="0" anchor="ctr"/>
-          <a:lstStyle/>
-          <a:p>
-            <a:pPr marL="0" indent="0">
-              <a:buNone/>
-            </a:pPr>
-            <a:r>
-              <a:rPr lang="en-US" sz="1700" b="1" dirty="0">
-                <a:solidFill>
-                  <a:schemeClr val="tx1"/>
-                </a:solidFill>
-              </a:rPr>
-              <a:t>Rigid Bodies</a:t>
-            </a:r>
-            <a:endParaRPr lang="en-US" sz="1700" dirty="0"/>
-          </a:p>
-        </p:txBody>
-      </p:sp>
-      <p:sp>
-        <p:nvSpPr>
-          <p:cNvPr id="11" name="t25"/>
-          <p:cNvSpPr txBox="1"/>
-          <p:nvPr/>
-        </p:nvSpPr>
-        <p:spPr>
-          <a:xfrm>
-            <a:off x="3611880" y="2185416"/>
-            <a:ext cx="960120" cy="658368"/>
-          </a:xfrm>
-          <a:prstGeom prst="rect">
-            <a:avLst/>
-          </a:prstGeom>
-          <a:noFill/>
-          <a:ln/>
-        </p:spPr>
-        <p:txBody>
-          <a:bodyPr wrap="square" lIns="0" tIns="0" rIns="0" bIns="0" rtlCol="0" anchor="ctr"/>
-          <a:lstStyle/>
-          <a:p>
-            <a:pPr marL="0" indent="0">
-              <a:buNone/>
-            </a:pPr>
-            <a:r>
-              <a:rPr lang="en-US" sz="1700" dirty="0">
-                <a:solidFill>
-                  <a:schemeClr val="tx2"/>
-                </a:solidFill>
-              </a:rPr>
-              <a:t>1</a:t>
-            </a:r>
-            <a:endParaRPr lang="en-US" sz="1700" dirty="0"/>
-          </a:p>
-        </p:txBody>
-      </p:sp>
-      <p:sp>
-        <p:nvSpPr>
-          <p:cNvPr id="12" name="t26"/>
-          <p:cNvSpPr txBox="1"/>
-          <p:nvPr/>
-        </p:nvSpPr>
-        <p:spPr>
-          <a:xfrm>
-            <a:off x="4754880" y="2185416"/>
-            <a:ext cx="2560320" cy="658368"/>
-          </a:xfrm>
-          <a:prstGeom prst="rect">
-            <a:avLst/>
-          </a:prstGeom>
-          <a:noFill/>
-          <a:ln/>
-        </p:spPr>
-        <p:txBody>
-          <a:bodyPr wrap="square" lIns="0" tIns="0" rIns="0" bIns="0" rtlCol="0" anchor="ctr"/>
-          <a:lstStyle/>
-          <a:p>
-            <a:pPr marL="0" indent="0">
-              <a:buNone/>
-            </a:pPr>
-            <a:r>
-              <a:rPr lang="en-US" sz="1700" dirty="0">
-                <a:solidFill>
-                  <a:schemeClr val="tx2"/>
-                </a:solidFill>
-              </a:rPr>
-              <a:t>2, joined at a hitch</a:t>
-            </a:r>
-            <a:endParaRPr lang="en-US" sz="1700" dirty="0"/>
-          </a:p>
-        </p:txBody>
-      </p:sp>
-      <p:sp>
-        <p:nvSpPr>
-          <p:cNvPr id="13" name="card27"/>
-          <p:cNvSpPr/>
-          <p:nvPr/>
-        </p:nvSpPr>
-        <p:spPr>
-          <a:xfrm>
-            <a:off x="548640" y="2898648"/>
-            <a:ext cx="6766560" cy="548640"/>
-          </a:xfrm>
-          <a:prstGeom prst="roundRect">
-            <a:avLst>
-              <a:gd name="adj" fmla="val 20000"/>
-            </a:avLst>
-          </a:prstGeom>
-          <a:solidFill>
-            <a:schemeClr val="bg1"/>
-          </a:solidFill>
-          <a:ln/>
-        </p:spPr>
-      </p:sp>
-      <p:sp>
-        <p:nvSpPr>
-          <p:cNvPr id="14" name="t28"/>
-          <p:cNvSpPr txBox="1"/>
-          <p:nvPr/>
-        </p:nvSpPr>
-        <p:spPr>
-          <a:xfrm>
-            <a:off x="731520" y="2843784"/>
-            <a:ext cx="2697480" cy="658368"/>
-          </a:xfrm>
-          <a:prstGeom prst="rect">
-            <a:avLst/>
-          </a:prstGeom>
-          <a:noFill/>
-          <a:ln/>
-        </p:spPr>
-        <p:txBody>
-          <a:bodyPr wrap="square" lIns="0" tIns="0" rIns="0" bIns="0" rtlCol="0" anchor="ctr"/>
-          <a:lstStyle/>
-          <a:p>
-            <a:pPr marL="0" indent="0">
-              <a:buNone/>
-            </a:pPr>
-            <a:r>
-              <a:rPr lang="en-US" sz="1700" b="1" dirty="0">
-                <a:solidFill>
-                  <a:schemeClr val="tx1"/>
-                </a:solidFill>
-              </a:rPr>
-              <a:t>State Variables</a:t>
-            </a:r>
-            <a:endParaRPr lang="en-US" sz="1700" dirty="0"/>
-          </a:p>
-        </p:txBody>
-      </p:sp>
-      <p:sp>
-        <p:nvSpPr>
-          <p:cNvPr id="15" name="t29"/>
-          <p:cNvSpPr txBox="1"/>
-          <p:nvPr/>
-        </p:nvSpPr>
-        <p:spPr>
-          <a:xfrm>
-            <a:off x="3611880" y="2843784"/>
-            <a:ext cx="960120" cy="658368"/>
-          </a:xfrm>
-          <a:prstGeom prst="rect">
-            <a:avLst/>
-          </a:prstGeom>
-          <a:noFill/>
-          <a:ln/>
-        </p:spPr>
-        <p:txBody>
-          <a:bodyPr wrap="square" lIns="0" tIns="0" rIns="0" bIns="0" rtlCol="0" anchor="ctr"/>
-          <a:lstStyle/>
-          <a:p>
-            <a:pPr marL="0" indent="0">
-              <a:buNone/>
-            </a:pPr>
-            <a:r>
-              <a:rPr lang="en-US" sz="1700" dirty="0">
-                <a:solidFill>
-                  <a:schemeClr val="tx2"/>
-                </a:solidFill>
-              </a:rPr>
-              <a:t>3</a:t>
-            </a:r>
-            <a:endParaRPr lang="en-US" sz="1700" dirty="0"/>
-          </a:p>
-        </p:txBody>
-      </p:sp>
-      <p:sp>
-        <p:nvSpPr>
-          <p:cNvPr id="16" name="t30"/>
-          <p:cNvSpPr txBox="1"/>
-          <p:nvPr/>
-        </p:nvSpPr>
-        <p:spPr>
-          <a:xfrm>
-            <a:off x="4754880" y="2843784"/>
-            <a:ext cx="2560320" cy="658368"/>
-          </a:xfrm>
-          <a:prstGeom prst="rect">
-            <a:avLst/>
-          </a:prstGeom>
-          <a:noFill/>
-          <a:ln/>
-        </p:spPr>
-        <p:txBody>
-          <a:bodyPr wrap="square" lIns="0" tIns="0" rIns="0" bIns="0" rtlCol="0" anchor="ctr"/>
-          <a:lstStyle/>
-          <a:p>
-            <a:pPr marL="0" indent="0">
-              <a:buNone/>
-            </a:pPr>
-            <a:r>
-              <a:rPr lang="en-US" sz="1700" dirty="0">
-                <a:solidFill>
-                  <a:schemeClr val="tx2"/>
-                </a:solidFill>
-              </a:rPr>
-              <a:t>4</a:t>
-            </a:r>
-            <a:endParaRPr lang="en-US" sz="1700" dirty="0"/>
-          </a:p>
-        </p:txBody>
-      </p:sp>
-      <p:sp>
-        <p:nvSpPr>
-          <p:cNvPr id="17" name="card31"/>
-          <p:cNvSpPr/>
-          <p:nvPr/>
-        </p:nvSpPr>
-        <p:spPr>
-          <a:xfrm>
-            <a:off x="548640" y="3557016"/>
-            <a:ext cx="6766560" cy="548640"/>
-          </a:xfrm>
-          <a:prstGeom prst="roundRect">
-            <a:avLst>
-              <a:gd name="adj" fmla="val 20000"/>
-            </a:avLst>
-          </a:prstGeom>
-          <a:solidFill>
-            <a:schemeClr val="bg2"/>
-          </a:solidFill>
-          <a:ln/>
-        </p:spPr>
-      </p:sp>
-      <p:sp>
-        <p:nvSpPr>
-          <p:cNvPr id="18" name="t32"/>
-          <p:cNvSpPr txBox="1"/>
-          <p:nvPr/>
-        </p:nvSpPr>
-        <p:spPr>
-          <a:xfrm>
-            <a:off x="731520" y="3502152"/>
-            <a:ext cx="2697480" cy="658368"/>
-          </a:xfrm>
-          <a:prstGeom prst="rect">
-            <a:avLst/>
-          </a:prstGeom>
-          <a:noFill/>
-          <a:ln/>
-        </p:spPr>
-        <p:txBody>
-          <a:bodyPr wrap="square" lIns="0" tIns="0" rIns="0" bIns="0" rtlCol="0" anchor="ctr"/>
-          <a:lstStyle/>
-          <a:p>
-            <a:pPr marL="0" indent="0">
-              <a:buNone/>
-            </a:pPr>
-            <a:r>
-              <a:rPr lang="en-US" sz="1700" b="1" dirty="0">
-                <a:solidFill>
-                  <a:schemeClr val="tx1"/>
-                </a:solidFill>
-              </a:rPr>
-              <a:t>Reversing</a:t>
-            </a:r>
-            <a:endParaRPr lang="en-US" sz="1700" dirty="0"/>
-          </a:p>
-        </p:txBody>
-      </p:sp>
-      <p:sp>
-        <p:nvSpPr>
-          <p:cNvPr id="19" name="t33"/>
-          <p:cNvSpPr txBox="1"/>
-          <p:nvPr/>
-        </p:nvSpPr>
-        <p:spPr>
-          <a:xfrm>
-            <a:off x="3611880" y="3502152"/>
-            <a:ext cx="960120" cy="658368"/>
-          </a:xfrm>
-          <a:prstGeom prst="rect">
-            <a:avLst/>
-          </a:prstGeom>
-          <a:noFill/>
-          <a:ln/>
-        </p:spPr>
-        <p:txBody>
-          <a:bodyPr wrap="square" lIns="0" tIns="0" rIns="0" bIns="0" rtlCol="0" anchor="ctr"/>
-          <a:lstStyle/>
-          <a:p>
-            <a:pPr marL="0" indent="0">
-              <a:buNone/>
-            </a:pPr>
-            <a:r>
-              <a:rPr lang="en-US" sz="1700" dirty="0">
-                <a:solidFill>
-                  <a:schemeClr val="tx2"/>
-                </a:solidFill>
-              </a:rPr>
-              <a:t>Stable</a:t>
-            </a:r>
-            <a:endParaRPr lang="en-US" sz="1700" dirty="0"/>
-          </a:p>
-        </p:txBody>
-      </p:sp>
-      <p:sp>
-        <p:nvSpPr>
-          <p:cNvPr id="20" name="t34"/>
-          <p:cNvSpPr txBox="1"/>
-          <p:nvPr/>
-        </p:nvSpPr>
-        <p:spPr>
-          <a:xfrm>
-            <a:off x="4754880" y="3502152"/>
-            <a:ext cx="2560320" cy="658368"/>
-          </a:xfrm>
-          <a:prstGeom prst="rect">
-            <a:avLst/>
-          </a:prstGeom>
-          <a:noFill/>
-          <a:ln/>
-        </p:spPr>
-        <p:txBody>
-          <a:bodyPr wrap="square" lIns="0" tIns="0" rIns="0" bIns="0" rtlCol="0" anchor="ctr"/>
-          <a:lstStyle/>
-          <a:p>
-            <a:pPr marL="0" indent="0">
-              <a:buNone/>
-            </a:pPr>
-            <a:r>
-              <a:rPr lang="en-US" sz="1700" dirty="0">
-                <a:solidFill>
-                  <a:schemeClr val="accent3"/>
-                </a:solidFill>
-              </a:rPr>
-              <a:t>Unstable: jackknifes</a:t>
-            </a:r>
-            <a:endParaRPr lang="en-US" sz="1700" dirty="0"/>
-          </a:p>
-        </p:txBody>
-      </p:sp>
-      <p:sp>
-        <p:nvSpPr>
-          <p:cNvPr id="21" name="card35"/>
-          <p:cNvSpPr/>
-          <p:nvPr/>
-        </p:nvSpPr>
-        <p:spPr>
-          <a:xfrm>
-            <a:off x="548640" y="4215384"/>
-            <a:ext cx="6766560" cy="548640"/>
-          </a:xfrm>
-          <a:prstGeom prst="roundRect">
-            <a:avLst>
-              <a:gd name="adj" fmla="val 20000"/>
-            </a:avLst>
-          </a:prstGeom>
-          <a:solidFill>
-            <a:schemeClr val="bg1"/>
-          </a:solidFill>
-          <a:ln/>
-        </p:spPr>
-      </p:sp>
-      <p:sp>
-        <p:nvSpPr>
-          <p:cNvPr id="22" name="t36"/>
-          <p:cNvSpPr txBox="1"/>
-          <p:nvPr/>
-        </p:nvSpPr>
-        <p:spPr>
-          <a:xfrm>
-            <a:off x="731520" y="4160520"/>
-            <a:ext cx="2697480" cy="658368"/>
-          </a:xfrm>
-          <a:prstGeom prst="rect">
-            <a:avLst/>
-          </a:prstGeom>
-          <a:noFill/>
-          <a:ln/>
-        </p:spPr>
-        <p:txBody>
-          <a:bodyPr wrap="square" lIns="0" tIns="0" rIns="0" bIns="0" rtlCol="0" anchor="ctr"/>
-          <a:lstStyle/>
-          <a:p>
-            <a:pPr marL="0" indent="0">
-              <a:buNone/>
-            </a:pPr>
-            <a:r>
-              <a:rPr lang="en-US" sz="1700" b="1" dirty="0">
-                <a:solidFill>
-                  <a:schemeClr val="tx1"/>
-                </a:solidFill>
-              </a:rPr>
-              <a:t>Self-Parking Today</a:t>
-            </a:r>
-            <a:endParaRPr lang="en-US" sz="1700" dirty="0"/>
-          </a:p>
-        </p:txBody>
-      </p:sp>
-      <p:sp>
-        <p:nvSpPr>
-          <p:cNvPr id="23" name="t37"/>
-          <p:cNvSpPr txBox="1"/>
-          <p:nvPr/>
-        </p:nvSpPr>
-        <p:spPr>
-          <a:xfrm>
-            <a:off x="3611880" y="4160520"/>
-            <a:ext cx="960120" cy="658368"/>
-          </a:xfrm>
-          <a:prstGeom prst="rect">
-            <a:avLst/>
-          </a:prstGeom>
-          <a:noFill/>
-          <a:ln/>
-        </p:spPr>
-        <p:txBody>
-          <a:bodyPr wrap="square" lIns="0" tIns="0" rIns="0" bIns="0" rtlCol="0" anchor="ctr"/>
-          <a:lstStyle/>
-          <a:p>
-            <a:pPr marL="0" indent="0">
-              <a:buNone/>
-            </a:pPr>
-            <a:r>
-              <a:rPr lang="en-US" sz="1700" dirty="0">
-                <a:solidFill>
-                  <a:schemeClr val="tx2"/>
-                </a:solidFill>
-              </a:rPr>
-              <a:t>Yes</a:t>
-            </a:r>
-            <a:endParaRPr lang="en-US" sz="1700" dirty="0"/>
-          </a:p>
-        </p:txBody>
-      </p:sp>
-      <p:sp>
-        <p:nvSpPr>
-          <p:cNvPr id="24" name="t38"/>
-          <p:cNvSpPr txBox="1"/>
-          <p:nvPr/>
-        </p:nvSpPr>
-        <p:spPr>
-          <a:xfrm>
-            <a:off x="4754880" y="4160520"/>
-            <a:ext cx="2560320" cy="658368"/>
-          </a:xfrm>
-          <a:prstGeom prst="rect">
-            <a:avLst/>
-          </a:prstGeom>
-          <a:noFill/>
-          <a:ln/>
-        </p:spPr>
-        <p:txBody>
-          <a:bodyPr wrap="square" lIns="0" tIns="0" rIns="0" bIns="0" rtlCol="0" anchor="ctr"/>
-          <a:lstStyle/>
-          <a:p>
-            <a:pPr marL="0" indent="0">
-              <a:buNone/>
-            </a:pPr>
-            <a:r>
-              <a:rPr lang="en-US" sz="1700" dirty="0">
-                <a:solidFill>
-                  <a:schemeClr val="tx2"/>
-                </a:solidFill>
-              </a:rPr>
-              <a:t>No</a:t>
-            </a:r>
-            <a:endParaRPr lang="en-US" sz="1700" dirty="0"/>
-          </a:p>
-        </p:txBody>
-      </p:sp>
-      <p:pic>
-        <p:nvPicPr>
-          <p:cNvPr id="25" name="img39" descr="Unaided reverse in our simulator: the trailer folds against the tractor"/>
-          <p:cNvPicPr>
-            <a:picLocks noChangeAspect="1"/>
-          </p:cNvPicPr>
-          <p:nvPr/>
-        </p:nvPicPr>
-        <p:blipFill>
-          <a:blip r:embed="rId3"/>
-          <a:stretch>
-            <a:fillRect/>
-          </a:stretch>
-        </p:blipFill>
-        <p:spPr>
-          <a:xfrm>
-            <a:off x="7543800" y="1527048"/>
-            <a:ext cx="4114800" cy="2834126"/>
-          </a:xfrm>
-          <a:prstGeom prst="rect">
-            <a:avLst/>
-          </a:prstGeom>
-        </p:spPr>
-      </p:pic>
-      <p:sp>
-        <p:nvSpPr>
-          <p:cNvPr id="26" name="t40"/>
-          <p:cNvSpPr txBox="1"/>
-          <p:nvPr/>
-        </p:nvSpPr>
-        <p:spPr>
-          <a:xfrm>
-            <a:off x="7543800" y="4407408"/>
-            <a:ext cx="4114800" cy="365760"/>
-          </a:xfrm>
-          <a:prstGeom prst="rect">
-            <a:avLst/>
-          </a:prstGeom>
-          <a:noFill/>
-          <a:ln/>
-        </p:spPr>
-        <p:txBody>
-          <a:bodyPr wrap="square" lIns="0" tIns="0" rIns="0" bIns="0" rtlCol="0" anchor="t"/>
-          <a:lstStyle/>
-          <a:p>
-            <a:pPr marL="0" indent="0" algn="r">
-              <a:buNone/>
-            </a:pPr>
-            <a:r>
-              <a:rPr lang="en-US" sz="1100" i="1" dirty="0">
-                <a:solidFill>
-                  <a:schemeClr val="accent4"/>
-                </a:solidFill>
-              </a:rPr>
-              <a:t>Unaided reverse in our simulator: the rig folds</a:t>
-            </a:r>
-            <a:endParaRPr lang="en-US" sz="1100" dirty="0"/>
-          </a:p>
-        </p:txBody>
-      </p:sp>
-      <p:sp>
-        <p:nvSpPr>
-          <p:cNvPr id="27" name="card41"/>
-          <p:cNvSpPr/>
-          <p:nvPr/>
-        </p:nvSpPr>
-        <p:spPr>
-          <a:xfrm>
-            <a:off x="548640" y="5120640"/>
-            <a:ext cx="11094415" cy="960120"/>
-          </a:xfrm>
-          <a:prstGeom prst="roundRect">
-            <a:avLst>
-              <a:gd name="adj" fmla="val 11429"/>
-            </a:avLst>
-          </a:prstGeom>
-          <a:solidFill>
-            <a:schemeClr val="accent6"/>
-          </a:solidFill>
-          <a:ln/>
-        </p:spPr>
-      </p:sp>
-      <p:sp>
-        <p:nvSpPr>
-          <p:cNvPr id="28" name="t42"/>
-          <p:cNvSpPr txBox="1"/>
-          <p:nvPr/>
-        </p:nvSpPr>
-        <p:spPr>
-          <a:xfrm>
-            <a:off x="822960" y="5120640"/>
-            <a:ext cx="10545775" cy="960120"/>
-          </a:xfrm>
-          <a:prstGeom prst="rect">
-            <a:avLst/>
-          </a:prstGeom>
-          <a:noFill/>
-          <a:ln/>
-        </p:spPr>
-        <p:txBody>
-          <a:bodyPr wrap="square" lIns="0" tIns="0" rIns="0" bIns="0" rtlCol="0" anchor="ctr"/>
-          <a:lstStyle/>
-          <a:p>
-            <a:pPr marL="0" indent="0">
-              <a:buNone/>
-            </a:pPr>
-            <a:r>
-              <a:rPr lang="en-US" sz="1700" b="1" dirty="0">
-                <a:solidFill>
-                  <a:schemeClr val="tx1"/>
-                </a:solidFill>
-              </a:rPr>
-              <a:t>Our Goal: </a:t>
-            </a:r>
-            <a:r>
-              <a:rPr lang="en-US" sz="1700" dirty="0">
-                <a:solidFill>
-                  <a:schemeClr val="tx1"/>
-                </a:solidFill>
-              </a:rPr>
-              <a:t>guide the truck from the gate into a chosen bay while the hitch angle never exceeds 60°</a:t>
-            </a:r>
-            <a:endParaRPr lang="en-US" sz="1700" dirty="0"/>
-          </a:p>
-        </p:txBody>
-      </p:sp>
-      <p:sp>
-        <p:nvSpPr>
-          <p:cNvPr id="29" name="Slide Number Placeholder 0"/>
-          <p:cNvSpPr>
-            <a:spLocks noGrp="1"/>
-          </p:cNvSpPr>
-          <p:nvPr>
-            <p:ph type="sldNum" sz="quarter" idx="4294967295"/>
-          </p:nvPr>
-        </p:nvSpPr>
-        <p:spPr>
-          <a:xfrm>
-            <a:off x="11094415" y="6355080"/>
-            <a:ext cx="548640" cy="274320"/>
-          </a:xfrm>
-          <a:prstGeom prst="rect">
-            <a:avLst/>
-          </a:prstGeom>
-          <a:extLst>
-            <a:ext uri="{C572A759-6A51-4108-AA02-DFA0A04FC94B}">
-              <ma14:wrappingTextBoxFlag xmlns:ma14="http://schemas.microsoft.com/office/mac/drawingml/2011/main" xmlns="" val="0"/>
-            </a:ext>
-          </a:extLst>
-        </p:spPr>
-        <p:txBody>
-          <a:bodyPr/>
-          <a:lstStyle>
-            <a:lvl1pPr>
-              <a:defRPr sz="1200">
-                <a:solidFill>
-                  <a:schemeClr val="accent4"/>
-                </a:solidFill>
-              </a:defRPr>
-            </a:lvl1pPr>
-          </a:lstStyle>
-          <a:p>
-            <a:pPr algn="r"/>
-            <a:fld id="{F7021451-1387-4CA6-816F-3879F97B5CBC}" type="slidenum">
-              <a:rPr lang="en-US" b="0"/>
-              <a:t>3</a:t>
-            </a:fld>
-            <a:endParaRPr lang="en-US"/>
-          </a:p>
-        </p:txBody>
-      </p:sp>
-    </p:spTree>
-  </p:cSld>
-  <p:clrMapOvr>
-    <a:masterClrMapping/>
-  </p:clrMapOvr>
-</p:sld>
-</file>
-
-<file path=ppt/slides/slide4.xml><?xml version="1.0" encoding="utf-8"?>
 <p:sld xmlns:a="http://schemas.openxmlformats.org/drawingml/2006/main" xmlns:r="http://schemas.openxmlformats.org/officeDocument/2006/relationships" xmlns:p="http://schemas.openxmlformats.org/presentationml/2006/main">
   <p:cSld name="Slide 4">
     <p:spTree>
@@ -12629,7 +11430,7 @@
           </a:prstGeom>
           <a:extLst>
             <a:ext uri="{C572A759-6A51-4108-AA02-DFA0A04FC94B}">
-              <ma14:wrappingTextBoxFlag xmlns:ma14="http://schemas.microsoft.com/office/mac/drawingml/2011/main" xmlns="" val="0"/>
+              <ma14:wrappingTextBoxFlag xmlns="" xmlns:ma14="http://schemas.microsoft.com/office/mac/drawingml/2011/main" val="0"/>
             </a:ext>
           </a:extLst>
         </p:spPr>
@@ -12648,7 +11449,7 @@
             <a:pPr algn="r"/>
             <a:fld id="{F7021451-1387-4CA6-816F-3879F97B5CBC}" type="slidenum">
               <a:rPr lang="en-US" b="0"/>
-              <a:t>4</a:t>
+              <a:t>3</a:t>
             </a:fld>
             <a:endParaRPr lang="en-US"/>
           </a:p>
@@ -12662,7 +11463,7 @@
 </p:sld>
 </file>
 
-<file path=ppt/slides/slide5.xml><?xml version="1.0" encoding="utf-8"?>
+<file path=ppt/slides/slide4.xml><?xml version="1.0" encoding="utf-8"?>
 <p:sld xmlns:a="http://schemas.openxmlformats.org/drawingml/2006/main" xmlns:r="http://schemas.openxmlformats.org/officeDocument/2006/relationships" xmlns:p="http://schemas.openxmlformats.org/presentationml/2006/main">
   <p:cSld name="Slide 5">
     <p:spTree>
@@ -12875,7 +11676,7 @@
           </a:prstGeom>
           <a:extLst>
             <a:ext uri="{C572A759-6A51-4108-AA02-DFA0A04FC94B}">
-              <ma14:wrappingTextBoxFlag xmlns:ma14="http://schemas.microsoft.com/office/mac/drawingml/2011/main" xmlns="" val="0"/>
+              <ma14:wrappingTextBoxFlag xmlns="" xmlns:ma14="http://schemas.microsoft.com/office/mac/drawingml/2011/main" val="0"/>
             </a:ext>
           </a:extLst>
         </p:spPr>
@@ -12894,7 +11695,7 @@
             <a:pPr algn="r"/>
             <a:fld id="{F7021451-1387-4CA6-816F-3879F97B5CBC}" type="slidenum">
               <a:rPr lang="en-US" b="0"/>
-              <a:t>5</a:t>
+              <a:t>4</a:t>
             </a:fld>
             <a:endParaRPr lang="en-US"/>
           </a:p>
@@ -12908,7 +11709,7 @@
 </p:sld>
 </file>
 
-<file path=ppt/slides/slide6.xml><?xml version="1.0" encoding="utf-8"?>
+<file path=ppt/slides/slide5.xml><?xml version="1.0" encoding="utf-8"?>
 <p:sld xmlns:a="http://schemas.openxmlformats.org/drawingml/2006/main" xmlns:r="http://schemas.openxmlformats.org/officeDocument/2006/relationships" xmlns:p="http://schemas.openxmlformats.org/presentationml/2006/main">
   <p:cSld name="Slide 6">
     <p:spTree>
@@ -13263,7 +12064,7 @@
           </a:prstGeom>
           <a:extLst>
             <a:ext uri="{C572A759-6A51-4108-AA02-DFA0A04FC94B}">
-              <ma14:wrappingTextBoxFlag xmlns:ma14="http://schemas.microsoft.com/office/mac/drawingml/2011/main" xmlns="" val="0"/>
+              <ma14:wrappingTextBoxFlag xmlns="" xmlns:ma14="http://schemas.microsoft.com/office/mac/drawingml/2011/main" val="0"/>
             </a:ext>
           </a:extLst>
         </p:spPr>
@@ -13282,7 +12083,7 @@
             <a:pPr algn="r"/>
             <a:fld id="{F7021451-1387-4CA6-816F-3879F97B5CBC}" type="slidenum">
               <a:rPr lang="en-US" b="0"/>
-              <a:t>6</a:t>
+              <a:t>5</a:t>
             </a:fld>
             <a:endParaRPr lang="en-US"/>
           </a:p>
@@ -13296,7 +12097,7 @@
 </p:sld>
 </file>
 
-<file path=ppt/slides/slide7.xml><?xml version="1.0" encoding="utf-8"?>
+<file path=ppt/slides/slide6.xml><?xml version="1.0" encoding="utf-8"?>
 <p:sld xmlns:a="http://schemas.openxmlformats.org/drawingml/2006/main" xmlns:r="http://schemas.openxmlformats.org/officeDocument/2006/relationships" xmlns:p="http://schemas.openxmlformats.org/presentationml/2006/main">
   <p:cSld name="Slide 7">
     <p:spTree>
@@ -13959,7 +12760,7 @@
           </a:prstGeom>
           <a:extLst>
             <a:ext uri="{C572A759-6A51-4108-AA02-DFA0A04FC94B}">
-              <ma14:wrappingTextBoxFlag xmlns:ma14="http://schemas.microsoft.com/office/mac/drawingml/2011/main" xmlns="" val="0"/>
+              <ma14:wrappingTextBoxFlag xmlns="" xmlns:ma14="http://schemas.microsoft.com/office/mac/drawingml/2011/main" val="0"/>
             </a:ext>
           </a:extLst>
         </p:spPr>
@@ -13978,7 +12779,7 @@
             <a:pPr algn="r"/>
             <a:fld id="{F7021451-1387-4CA6-816F-3879F97B5CBC}" type="slidenum">
               <a:rPr lang="en-US" b="0"/>
-              <a:t>7</a:t>
+              <a:t>6</a:t>
             </a:fld>
             <a:endParaRPr lang="en-US"/>
           </a:p>
@@ -13992,7 +12793,7 @@
 </p:sld>
 </file>
 
-<file path=ppt/slides/slide8.xml><?xml version="1.0" encoding="utf-8"?>
+<file path=ppt/slides/slide7.xml><?xml version="1.0" encoding="utf-8"?>
 <p:sld xmlns:a="http://schemas.openxmlformats.org/drawingml/2006/main" xmlns:r="http://schemas.openxmlformats.org/officeDocument/2006/relationships" xmlns:p="http://schemas.openxmlformats.org/presentationml/2006/main">
   <p:cSld name="Slide 8">
     <p:spTree>
@@ -14954,7 +13755,7 @@
           </a:prstGeom>
           <a:extLst>
             <a:ext uri="{C572A759-6A51-4108-AA02-DFA0A04FC94B}">
-              <ma14:wrappingTextBoxFlag xmlns:ma14="http://schemas.microsoft.com/office/mac/drawingml/2011/main" xmlns="" val="0"/>
+              <ma14:wrappingTextBoxFlag xmlns="" xmlns:ma14="http://schemas.microsoft.com/office/mac/drawingml/2011/main" val="0"/>
             </a:ext>
           </a:extLst>
         </p:spPr>
@@ -14973,7 +13774,7 @@
             <a:pPr algn="r"/>
             <a:fld id="{F7021451-1387-4CA6-816F-3879F97B5CBC}" type="slidenum">
               <a:rPr lang="en-US" b="0"/>
-              <a:t>8</a:t>
+              <a:t>7</a:t>
             </a:fld>
             <a:endParaRPr lang="en-US"/>
           </a:p>
@@ -14987,7 +13788,7 @@
 </p:sld>
 </file>
 
-<file path=ppt/slides/slide9.xml><?xml version="1.0" encoding="utf-8"?>
+<file path=ppt/slides/slide8.xml><?xml version="1.0" encoding="utf-8"?>
 <p:sld xmlns:a="http://schemas.openxmlformats.org/drawingml/2006/main" xmlns:r="http://schemas.openxmlformats.org/officeDocument/2006/relationships" xmlns:p="http://schemas.openxmlformats.org/presentationml/2006/main">
   <p:cSld name="Slide 9">
     <p:spTree>
@@ -15200,7 +14001,449 @@
           </a:prstGeom>
           <a:extLst>
             <a:ext uri="{C572A759-6A51-4108-AA02-DFA0A04FC94B}">
-              <ma14:wrappingTextBoxFlag xmlns:ma14="http://schemas.microsoft.com/office/mac/drawingml/2011/main" xmlns="" val="0"/>
+              <ma14:wrappingTextBoxFlag xmlns="" xmlns:ma14="http://schemas.microsoft.com/office/mac/drawingml/2011/main" val="0"/>
+            </a:ext>
+          </a:extLst>
+        </p:spPr>
+        <p:txBody>
+          <a:bodyPr/>
+          <a:lstStyle>
+            <a:lvl1pPr>
+              <a:defRPr sz="1200">
+                <a:solidFill>
+                  <a:schemeClr val="accent4"/>
+                </a:solidFill>
+              </a:defRPr>
+            </a:lvl1pPr>
+          </a:lstStyle>
+          <a:p>
+            <a:pPr algn="r"/>
+            <a:fld id="{F7021451-1387-4CA6-816F-3879F97B5CBC}" type="slidenum">
+              <a:rPr lang="en-US" b="0"/>
+              <a:t>8</a:t>
+            </a:fld>
+            <a:endParaRPr lang="en-US"/>
+          </a:p>
+        </p:txBody>
+      </p:sp>
+    </p:spTree>
+  </p:cSld>
+  <p:clrMapOvr>
+    <a:masterClrMapping/>
+  </p:clrMapOvr>
+</p:sld>
+</file>
+
+<file path=ppt/slides/slide9.xml><?xml version="1.0" encoding="utf-8"?>
+<p:sld xmlns:a="http://schemas.openxmlformats.org/drawingml/2006/main" xmlns:r="http://schemas.openxmlformats.org/officeDocument/2006/relationships" xmlns:p="http://schemas.openxmlformats.org/presentationml/2006/main">
+  <p:cSld name="Slide 10">
+    <p:spTree>
+      <p:nvGrpSpPr>
+        <p:cNvPr id="1" name=""/>
+        <p:cNvGrpSpPr/>
+        <p:nvPr/>
+      </p:nvGrpSpPr>
+      <p:grpSpPr>
+        <a:xfrm>
+          <a:off x="0" y="0"/>
+          <a:ext cx="0" cy="0"/>
+          <a:chOff x="0" y="0"/>
+          <a:chExt cx="0" cy="0"/>
+        </a:xfrm>
+      </p:grpSpPr>
+      <p:sp>
+        <p:nvSpPr>
+          <p:cNvPr id="2" name="badge122"/>
+          <p:cNvSpPr/>
+          <p:nvPr/>
+        </p:nvSpPr>
+        <p:spPr>
+          <a:xfrm>
+            <a:off x="548640" y="356616"/>
+            <a:ext cx="256032" cy="256032"/>
+          </a:xfrm>
+          <a:prstGeom prst="ellipse">
+            <a:avLst/>
+          </a:prstGeom>
+          <a:solidFill>
+            <a:schemeClr val="accent1"/>
+          </a:solidFill>
+          <a:ln/>
+        </p:spPr>
+      </p:sp>
+      <p:sp>
+        <p:nvSpPr>
+          <p:cNvPr id="3" name="t123"/>
+          <p:cNvSpPr txBox="1"/>
+          <p:nvPr/>
+        </p:nvSpPr>
+        <p:spPr>
+          <a:xfrm>
+            <a:off x="548640" y="356616"/>
+            <a:ext cx="256032" cy="256032"/>
+          </a:xfrm>
+          <a:prstGeom prst="rect">
+            <a:avLst/>
+          </a:prstGeom>
+          <a:noFill/>
+          <a:ln/>
+        </p:spPr>
+        <p:txBody>
+          <a:bodyPr wrap="square" lIns="0" tIns="0" rIns="0" bIns="0" rtlCol="0" anchor="ctr"/>
+          <a:lstStyle/>
+          <a:p>
+            <a:pPr marL="0" indent="0" algn="ctr">
+              <a:buNone/>
+            </a:pPr>
+            <a:r>
+              <a:rPr lang="en-US" sz="1100" b="1" dirty="0">
+                <a:solidFill>
+                  <a:schemeClr val="bg1"/>
+                </a:solidFill>
+              </a:rPr>
+              <a:t>2</a:t>
+            </a:r>
+            <a:endParaRPr lang="en-US" sz="1100" dirty="0"/>
+          </a:p>
+        </p:txBody>
+      </p:sp>
+      <p:sp>
+        <p:nvSpPr>
+          <p:cNvPr id="4" name="Text 0"/>
+          <p:cNvSpPr>
+            <a:spLocks noGrp="1"/>
+          </p:cNvSpPr>
+          <p:nvPr>
+            <p:ph type="body" idx="100" hasCustomPrompt="1"/>
+          </p:nvPr>
+        </p:nvSpPr>
+        <p:spPr>
+          <a:xfrm>
+            <a:off x="960120" y="329184"/>
+            <a:ext cx="7315200" cy="310896"/>
+          </a:xfrm>
+          <a:prstGeom prst="rect">
+            <a:avLst/>
+          </a:prstGeom>
+          <a:noFill/>
+          <a:ln/>
+        </p:spPr>
+        <p:txBody>
+          <a:bodyPr wrap="square" lIns="0" tIns="0" rIns="0" bIns="0" rtlCol="0" anchor="ctr"/>
+          <a:lstStyle/>
+          <a:p>
+            <a:pPr marL="0" indent="0">
+              <a:buNone/>
+            </a:pPr>
+            <a:r>
+              <a:rPr lang="en-US" sz="1300" b="1" dirty="0">
+                <a:solidFill>
+                  <a:schemeClr val="accent1"/>
+                </a:solidFill>
+              </a:rPr>
+              <a:t>Part 2  ·  Vehicle Kinematics</a:t>
+            </a:r>
+            <a:endParaRPr lang="en-US" sz="1300" dirty="0"/>
+          </a:p>
+        </p:txBody>
+      </p:sp>
+      <p:sp>
+        <p:nvSpPr>
+          <p:cNvPr id="5" name="Text 0"/>
+          <p:cNvSpPr>
+            <a:spLocks noGrp="1"/>
+          </p:cNvSpPr>
+          <p:nvPr>
+            <p:ph type="title" idx="101" hasCustomPrompt="1"/>
+          </p:nvPr>
+        </p:nvSpPr>
+        <p:spPr>
+          <a:xfrm>
+            <a:off x="548640" y="676656"/>
+            <a:ext cx="11094415" cy="658368"/>
+          </a:xfrm>
+          <a:prstGeom prst="rect">
+            <a:avLst/>
+          </a:prstGeom>
+          <a:noFill/>
+          <a:ln/>
+        </p:spPr>
+        <p:txBody>
+          <a:bodyPr wrap="square" lIns="0" tIns="0" rIns="0" bIns="0" rtlCol="0" anchor="ctr"/>
+          <a:lstStyle/>
+          <a:p>
+            <a:pPr marL="0" indent="0" algn="l">
+              <a:buNone/>
+            </a:pPr>
+            <a:r>
+              <a:rPr lang="en-US" sz="2800" dirty="0">
+                <a:solidFill>
+                  <a:schemeClr val="tx1"/>
+                </a:solidFill>
+              </a:rPr>
+              <a:t>The Tractor: Kinematic Bicycle Model</a:t>
+            </a:r>
+            <a:endParaRPr lang="en-US" sz="2800" dirty="0"/>
+          </a:p>
+        </p:txBody>
+      </p:sp>
+      <p:pic>
+        <p:nvPicPr>
+          <p:cNvPr id="6" name="img124" descr="Bicycle model: rear and front wheel, steering angle delta, both wheel axes meeting at the instantaneous centre of rotation at radius R"/>
+          <p:cNvPicPr>
+            <a:picLocks noChangeAspect="1"/>
+          </p:cNvPicPr>
+          <p:nvPr/>
+        </p:nvPicPr>
+        <p:blipFill>
+          <a:blip r:embed="rId3"/>
+          <a:stretch>
+            <a:fillRect/>
+          </a:stretch>
+        </p:blipFill>
+        <p:spPr>
+          <a:xfrm>
+            <a:off x="457200" y="1344168"/>
+            <a:ext cx="4928461" cy="4846320"/>
+          </a:xfrm>
+          <a:prstGeom prst="rect">
+            <a:avLst/>
+          </a:prstGeom>
+        </p:spPr>
+      </p:pic>
+      <p:sp>
+        <p:nvSpPr>
+          <p:cNvPr id="7" name="t125"/>
+          <p:cNvSpPr txBox="1"/>
+          <p:nvPr/>
+        </p:nvSpPr>
+        <p:spPr>
+          <a:xfrm>
+            <a:off x="5989320" y="1481328"/>
+            <a:ext cx="5653735" cy="1554480"/>
+          </a:xfrm>
+          <a:prstGeom prst="rect">
+            <a:avLst/>
+          </a:prstGeom>
+          <a:noFill/>
+          <a:ln/>
+        </p:spPr>
+        <p:txBody>
+          <a:bodyPr wrap="square" lIns="0" tIns="0" rIns="0" bIns="0" rtlCol="0" anchor="t"/>
+          <a:lstStyle/>
+          <a:p>
+            <a:pPr marL="203200" indent="-203200">
+              <a:spcAft>
+                <a:spcPts val="600"/>
+              </a:spcAft>
+              <a:buSzPct val="100000"/>
+              <a:buChar char="•"/>
+            </a:pPr>
+            <a:r>
+              <a:rPr lang="en-US" sz="1700" dirty="0">
+                <a:solidFill>
+                  <a:schemeClr val="tx2"/>
+                </a:solidFill>
+              </a:rPr>
+              <a:t>Front wheels lumped into one, rear wheels into one</a:t>
+            </a:r>
+            <a:endParaRPr lang="en-US" sz="1700" dirty="0"/>
+          </a:p>
+          <a:p>
+            <a:pPr marL="203200" indent="-203200">
+              <a:spcAft>
+                <a:spcPts val="600"/>
+              </a:spcAft>
+              <a:buSzPct val="100000"/>
+              <a:buChar char="•"/>
+            </a:pPr>
+            <a:r>
+              <a:rPr lang="en-US" sz="1700" dirty="0">
+                <a:solidFill>
+                  <a:schemeClr val="tx2"/>
+                </a:solidFill>
+              </a:rPr>
+              <a:t>Both wheel axes meet at the instantaneous centre of rotation (ICR)</a:t>
+            </a:r>
+            <a:endParaRPr lang="en-US" sz="1700" dirty="0"/>
+          </a:p>
+        </p:txBody>
+      </p:sp>
+      <p:pic>
+        <p:nvPicPr>
+          <p:cNvPr id="8" name="img126" descr="R equals L1 over tan delta"/>
+          <p:cNvPicPr>
+            <a:picLocks noChangeAspect="1"/>
+          </p:cNvPicPr>
+          <p:nvPr/>
+        </p:nvPicPr>
+        <p:blipFill>
+          <a:blip r:embed="rId4"/>
+          <a:stretch>
+            <a:fillRect/>
+          </a:stretch>
+        </p:blipFill>
+        <p:spPr>
+          <a:xfrm>
+            <a:off x="6309360" y="2532888"/>
+            <a:ext cx="1225296" cy="636422"/>
+          </a:xfrm>
+          <a:prstGeom prst="rect">
+            <a:avLst/>
+          </a:prstGeom>
+        </p:spPr>
+      </p:pic>
+      <p:sp>
+        <p:nvSpPr>
+          <p:cNvPr id="9" name="card127"/>
+          <p:cNvSpPr/>
+          <p:nvPr/>
+        </p:nvSpPr>
+        <p:spPr>
+          <a:xfrm>
+            <a:off x="5989320" y="3630168"/>
+            <a:ext cx="5653735" cy="1965960"/>
+          </a:xfrm>
+          <a:prstGeom prst="roundRect">
+            <a:avLst>
+              <a:gd name="adj" fmla="val 5581"/>
+            </a:avLst>
+          </a:prstGeom>
+          <a:solidFill>
+            <a:schemeClr val="accent5"/>
+          </a:solidFill>
+          <a:ln/>
+        </p:spPr>
+      </p:sp>
+      <p:sp>
+        <p:nvSpPr>
+          <p:cNvPr id="10" name="t128"/>
+          <p:cNvSpPr txBox="1"/>
+          <p:nvPr/>
+        </p:nvSpPr>
+        <p:spPr>
+          <a:xfrm>
+            <a:off x="6263640" y="3721608"/>
+            <a:ext cx="5105095" cy="365760"/>
+          </a:xfrm>
+          <a:prstGeom prst="rect">
+            <a:avLst/>
+          </a:prstGeom>
+          <a:noFill/>
+          <a:ln/>
+        </p:spPr>
+        <p:txBody>
+          <a:bodyPr wrap="square" lIns="0" tIns="0" rIns="0" bIns="0" rtlCol="0" anchor="t"/>
+          <a:lstStyle/>
+          <a:p>
+            <a:pPr marL="0" indent="0">
+              <a:buNone/>
+            </a:pPr>
+            <a:r>
+              <a:rPr lang="en-US" sz="1400" b="1" dirty="0">
+                <a:solidFill>
+                  <a:schemeClr val="accent1"/>
+                </a:solidFill>
+              </a:rPr>
+              <a:t>Rear-Axle Motion</a:t>
+            </a:r>
+            <a:endParaRPr lang="en-US" sz="1400" dirty="0"/>
+          </a:p>
+        </p:txBody>
+      </p:sp>
+      <p:pic>
+        <p:nvPicPr>
+          <p:cNvPr id="11" name="img129" descr="x1 dot equals v cos theta0"/>
+          <p:cNvPicPr>
+            <a:picLocks noChangeAspect="1"/>
+          </p:cNvPicPr>
+          <p:nvPr/>
+        </p:nvPicPr>
+        <p:blipFill>
+          <a:blip r:embed="rId5"/>
+          <a:stretch>
+            <a:fillRect/>
+          </a:stretch>
+        </p:blipFill>
+        <p:spPr>
+          <a:xfrm>
+            <a:off x="6263640" y="4178808"/>
+            <a:ext cx="1558138" cy="354787"/>
+          </a:xfrm>
+          <a:prstGeom prst="rect">
+            <a:avLst/>
+          </a:prstGeom>
+        </p:spPr>
+      </p:pic>
+      <p:pic>
+        <p:nvPicPr>
+          <p:cNvPr id="12" name="img130" descr="y1 dot equals v sin theta0"/>
+          <p:cNvPicPr>
+            <a:picLocks noChangeAspect="1"/>
+          </p:cNvPicPr>
+          <p:nvPr/>
+        </p:nvPicPr>
+        <p:blipFill>
+          <a:blip r:embed="rId6"/>
+          <a:stretch>
+            <a:fillRect/>
+          </a:stretch>
+        </p:blipFill>
+        <p:spPr>
+          <a:xfrm>
+            <a:off x="6263640" y="4818888"/>
+            <a:ext cx="1499616" cy="354787"/>
+          </a:xfrm>
+          <a:prstGeom prst="rect">
+            <a:avLst/>
+          </a:prstGeom>
+        </p:spPr>
+      </p:pic>
+      <p:pic>
+        <p:nvPicPr>
+          <p:cNvPr id="13" name="img131" descr="theta0 dot equals v over R equals v over L1 tan delta"/>
+          <p:cNvPicPr>
+            <a:picLocks noChangeAspect="1"/>
+          </p:cNvPicPr>
+          <p:nvPr/>
+        </p:nvPicPr>
+        <p:blipFill>
+          <a:blip r:embed="rId7"/>
+          <a:stretch>
+            <a:fillRect/>
+          </a:stretch>
+        </p:blipFill>
+        <p:spPr>
+          <a:xfrm>
+            <a:off x="8732520" y="4478731"/>
+            <a:ext cx="2260397" cy="588874"/>
+          </a:xfrm>
+          <a:prstGeom prst="rect">
+            <a:avLst/>
+          </a:prstGeom>
+        </p:spPr>
+      </p:pic>
+      <p:sp>
+        <p:nvSpPr>
+          <p:cNvPr id="25" name="Slide Number Placeholder 0"/>
+          <p:cNvSpPr>
+            <a:spLocks noGrp="1"/>
+          </p:cNvSpPr>
+          <p:nvPr>
+            <p:ph type="sldNum" sz="quarter" idx="4294967295"/>
+          </p:nvPr>
+        </p:nvSpPr>
+        <p:spPr>
+          <a:xfrm>
+            <a:off x="11094415" y="6355080"/>
+            <a:ext cx="548640" cy="274320"/>
+          </a:xfrm>
+          <a:prstGeom prst="rect">
+            <a:avLst/>
+          </a:prstGeom>
+          <a:extLst>
+            <a:ext uri="{C572A759-6A51-4108-AA02-DFA0A04FC94B}">
+              <ma14:wrappingTextBoxFlag xmlns="" xmlns:ma14="http://schemas.microsoft.com/office/mac/drawingml/2011/main" val="0"/>
             </a:ext>
           </a:extLst>
         </p:spPr>

</xml_diff>